<commit_message>
feat: Update SIH problem statement to SIH26150 (NTRO), embed high-res architecture model diagram, and restructure Slides 2 & 3 with Agentic AI Voice Module
</commit_message>
<xml_diff>
--- a/frontend/public/SIH_Ideate_Template_AAROHAN-X.pptx
+++ b/frontend/public/SIH_Ideate_Template_AAROHAN-X.pptx
@@ -7546,15 +7546,16 @@
           </a:bodyPr>
           <a:lstStyle/>
           <a:p>
-            <a:pPr/>
+            <a:pPr>
+              <a:defRPr sz="1300" b="1">
+                <a:solidFill>
+                  <a:srgbClr val="38BDF8"/>
+                </a:solidFill>
+                <a:latin typeface="Segoe UI"/>
+              </a:defRPr>
+            </a:pPr>
             <a:r>
-              <a:rPr sz="1400" b="1">
-                <a:solidFill>
-                  <a:srgbClr val="1B4353"/>
-                </a:solidFill>
-                <a:latin typeface="Georgia"/>
-              </a:rPr>
-              <a:t>NCIS-TACTICAL : AI-Powered Criminal Network &amp; Forensic Investigation Platform</a:t>
+              <a:t>NCIS-TACTICAL : Multi-Vendor DVR/NVR Forensic Analysis &amp; Intelligence Platform</a:t>
             </a:r>
           </a:p>
         </p:txBody>
@@ -7591,15 +7592,15 @@
               <a:spcAft>
                 <a:spcPts val="0"/>
               </a:spcAft>
+              <a:defRPr sz="1100" b="1">
+                <a:solidFill>
+                  <a:srgbClr val="FBBF24"/>
+                </a:solidFill>
+                <a:latin typeface="Segoe UI"/>
+              </a:defRPr>
             </a:pPr>
             <a:r>
-              <a:rPr sz="1100" b="1">
-                <a:solidFill>
-                  <a:srgbClr val="1B4353"/>
-                </a:solidFill>
-                <a:latin typeface="Georgia"/>
-              </a:rPr>
-              <a:t>Problem Statement ID  –  189</a:t>
+              <a:t>Problem Statement ID  –  SIH26150</a:t>
             </a:r>
             <a:endParaRPr sz="1000" b="0" i="0" u="none" strike="noStrike" cap="none">
               <a:solidFill>
@@ -7639,20 +7640,14 @@
           <a:lstStyle/>
           <a:p>
             <a:pPr>
-              <a:defRPr sz="1000" b="1">
-                <a:solidFill>
-                  <a:srgbClr val="154360"/>
-                </a:solidFill>
-                <a:latin typeface="Times New Roman"/>
+              <a:defRPr sz="950" b="0">
+                <a:solidFill>
+                  <a:srgbClr val="FFFFFF"/>
+                </a:solidFill>
+                <a:latin typeface="Segoe UI"/>
               </a:defRPr>
             </a:pPr>
             <a:r>
-              <a:rPr sz="1100" b="1">
-                <a:solidFill>
-                  <a:srgbClr val="1B4353"/>
-                </a:solidFill>
-                <a:latin typeface="Georgia"/>
-              </a:rPr>
               <a:t>Problem Statement Title  –</a:t>
             </a:r>
           </a:p>
@@ -7684,21 +7679,15 @@
           <a:lstStyle/>
           <a:p>
             <a:pPr>
-              <a:defRPr sz="900" b="0">
-                <a:solidFill>
-                  <a:srgbClr val="2C3E50"/>
-                </a:solidFill>
-                <a:latin typeface="Times New Roman"/>
+              <a:defRPr sz="900" b="1">
+                <a:solidFill>
+                  <a:srgbClr val="CBD5E1"/>
+                </a:solidFill>
+                <a:latin typeface="Segoe UI"/>
               </a:defRPr>
             </a:pPr>
             <a:r>
-              <a:rPr sz="950" b="0">
-                <a:solidFill>
-                  <a:srgbClr val="2C3E50"/>
-                </a:solidFill>
-                <a:latin typeface="Georgia"/>
-              </a:rPr>
-              <a:t>AI-Powered Criminal Network Analysis System (Bureau of Police Research &amp; Development / Ministry of Home Affairs)</a:t>
+              <a:t>Development of a Multi-Vendor DVR/NVR Forensic Analysis Tool for Standardized Acquisition, Recovery, and Analysis of Surveillance Evidence (National Technical Research Organisation - NTRO)</a:t>
             </a:r>
           </a:p>
         </p:txBody>
@@ -7735,15 +7724,15 @@
               <a:spcAft>
                 <a:spcPts val="0"/>
               </a:spcAft>
-              <a:defRPr sz="1000" b="1">
-                <a:solidFill>
-                  <a:srgbClr val="1B4353"/>
-                </a:solidFill>
-                <a:latin typeface="Georgia"/>
+              <a:defRPr sz="950" b="0">
+                <a:solidFill>
+                  <a:srgbClr val="FFFFFF"/>
+                </a:solidFill>
+                <a:latin typeface="Segoe UI"/>
               </a:defRPr>
             </a:pPr>
             <a:r>
-              <a:t>Theme  –  Smart Automation / Cyber Security &amp; Law Enforcement (Featuring Case Copilot Voice AI)</a:t>
+              <a:t>Theme  –  Cyber Security &amp; Digital Forensics / Surveillance Evidence Extraction (Featuring Agentic Voice AI)</a:t>
             </a:r>
             <a:endParaRPr sz="1000" b="0" i="0" u="none" strike="noStrike" cap="none">
               <a:solidFill>
@@ -7783,15 +7772,15 @@
           <a:lstStyle/>
           <a:p>
             <a:pPr>
-              <a:defRPr sz="1000" b="1">
-                <a:solidFill>
-                  <a:srgbClr val="1B4353"/>
-                </a:solidFill>
-                <a:latin typeface="Georgia"/>
+              <a:defRPr sz="950" b="0">
+                <a:solidFill>
+                  <a:srgbClr val="FFFFFF"/>
+                </a:solidFill>
+                <a:latin typeface="Segoe UI"/>
               </a:defRPr>
             </a:pPr>
             <a:r>
-              <a:t>PS Category  –  Software (with Tactical Forensic Hardware Terminal &amp; Siri Voice Agent)</a:t>
+              <a:t>PS Category  –  Software (with Tactical Forensic Hardware Terminal &amp; Agentic AI Voice Module)</a:t>
             </a:r>
           </a:p>
         </p:txBody>
@@ -7828,11 +7817,11 @@
               <a:spcAft>
                 <a:spcPts val="0"/>
               </a:spcAft>
-              <a:defRPr sz="1000" b="1">
-                <a:solidFill>
-                  <a:srgbClr val="1B4353"/>
-                </a:solidFill>
-                <a:latin typeface="Georgia"/>
+              <a:defRPr sz="950" b="0">
+                <a:solidFill>
+                  <a:srgbClr val="FFFFFF"/>
+                </a:solidFill>
+                <a:latin typeface="Segoe UI"/>
               </a:defRPr>
             </a:pPr>
             <a:r>
@@ -7882,14 +7871,14 @@
               <a:spcAft>
                 <a:spcPts val="0"/>
               </a:spcAft>
+              <a:defRPr sz="950" b="0">
+                <a:solidFill>
+                  <a:srgbClr val="FFFFFF"/>
+                </a:solidFill>
+                <a:latin typeface="Segoe UI"/>
+              </a:defRPr>
             </a:pPr>
             <a:r>
-              <a:rPr sz="1000" b="1">
-                <a:solidFill>
-                  <a:srgbClr val="1B4353"/>
-                </a:solidFill>
-                <a:latin typeface="Georgia"/>
-              </a:rPr>
               <a:t>Team ID  –  T-SIH2026-89412</a:t>
             </a:r>
             <a:endParaRPr sz="1000" b="0" i="0" u="none" strike="noStrike" cap="none">
@@ -8038,16 +8027,13 @@
           </a:bodyPr>
           <a:lstStyle/>
           <a:p>
-            <a:pPr>
-              <a:defRPr sz="1600" b="1">
-                <a:solidFill>
-                  <a:srgbClr val="1B4353"/>
-                </a:solidFill>
-                <a:latin typeface="Georgia"/>
-              </a:defRPr>
-            </a:pPr>
             <a:r>
-              <a:t>PROPOSED SOLUTION — NCIS-TACTICAL (WITH CASE COPILOT &amp; SIH26150)</a:t>
+              <a:rPr sz="1300" b="1">
+                <a:solidFill>
+                  <a:srgbClr val="38BDF8"/>
+                </a:solidFill>
+              </a:rPr>
+              <a:t>PROPOSED SOLUTION — NCIS-TACTICAL (SIH26150 MULTI-VENDOR DVR/NVR &amp; AGENTIC AI)</a:t>
             </a:r>
           </a:p>
         </p:txBody>
@@ -8245,18 +8231,15 @@
               <a:buSzPts val="1200"/>
               <a:buFont typeface="Cambria"/>
               <a:buNone/>
+              <a:defRPr sz="800" b="0">
+                <a:solidFill>
+                  <a:srgbClr val="CBD5E1"/>
+                </a:solidFill>
+                <a:latin typeface="Segoe UI"/>
+              </a:defRPr>
             </a:pPr>
             <a:r>
-              <a:rPr lang="en" sz="1200" b="1" i="0" u="none" strike="noStrike" cap="none" dirty="0">
-                <a:solidFill>
-                  <a:srgbClr val="CA6F1E"/>
-                </a:solidFill>
-                <a:latin typeface="Times New Roman" panose="02020603050405020304" pitchFamily="18" charset="0"/>
-                <a:ea typeface="Cambria"/>
-                <a:cs typeface="Times New Roman" panose="02020603050405020304" pitchFamily="18" charset="0"/>
-                <a:sym typeface="Cambria"/>
-              </a:rPr>
-              <a:t>Problem at Hand</a:t>
+              <a:t>The Unstructured Surveillance &amp; Evidence Challenge</a:t>
             </a:r>
             <a:endParaRPr sz="1200" b="0" i="0" u="none" strike="noStrike" cap="none" dirty="0">
               <a:solidFill>
@@ -8348,27 +8331,28 @@
               <a:spcAft>
                 <a:spcPts val="0"/>
               </a:spcAft>
+              <a:defRPr sz="800" b="0">
+                <a:solidFill>
+                  <a:srgbClr val="CBD5E1"/>
+                </a:solidFill>
+                <a:latin typeface="Segoe UI"/>
+              </a:defRPr>
             </a:pPr>
             <a:r>
-              <a:rPr sz="850" b="1">
-                <a:solidFill>
-                  <a:srgbClr val="B83A24"/>
-                </a:solidFill>
-                <a:latin typeface="Georgia"/>
-              </a:rPr>
-              <a:t>Core Problem :</a:t>
+              <a:t>Core Problem — Proprietary Surveillance Chaos (SIH26150):</a:t>
             </a:r>
           </a:p>
           <a:p>
-            <a:pPr/>
+            <a:pPr>
+              <a:defRPr sz="800" b="0">
+                <a:solidFill>
+                  <a:srgbClr val="CBD5E1"/>
+                </a:solidFill>
+                <a:latin typeface="Segoe UI"/>
+              </a:defRPr>
+            </a:pPr>
             <a:r>
-              <a:rPr sz="750" b="0">
-                <a:solidFill>
-                  <a:srgbClr val="2C3E50"/>
-                </a:solidFill>
-                <a:latin typeface="Georgia"/>
-              </a:rPr>
-              <a:t>Police &amp; intelligence agencies collect fragmented crime data across 7 disparate sources (FIRs, CDRs, Hawala, CCTV, OSINT, NCRB, NATGRID). Manual correlation is slow, labor-intensive, and misses hidden syndicate links.</a:t>
+              <a:t>Law enforcement struggles with heterogeneous CCTV/DVR/NVR systems (Hikvision, Dahua, CP Plus, Honeywell, Uniview) using proprietary filesystems (DHFS, HIK, WFS). Unstructured video, missing codecs, and corrupt sectors delay forensics by 7–30 days.</a:t>
             </a:r>
           </a:p>
         </p:txBody>
@@ -8451,28 +8435,28 @@
               <a:spcAft>
                 <a:spcPts val="0"/>
               </a:spcAft>
-              <a:defRPr sz="850" b="1">
-                <a:solidFill>
-                  <a:srgbClr val="B83A24"/>
-                </a:solidFill>
-                <a:latin typeface="Georgia"/>
+              <a:defRPr sz="800" b="0">
+                <a:solidFill>
+                  <a:srgbClr val="CBD5E1"/>
+                </a:solidFill>
+                <a:latin typeface="Segoe UI"/>
               </a:defRPr>
             </a:pPr>
             <a:r>
-              <a:t>Gap In Existing Solutions :</a:t>
+              <a:t>Gap In Existing Solutions:</a:t>
             </a:r>
           </a:p>
           <a:p>
             <a:pPr>
-              <a:defRPr sz="850" b="1">
-                <a:solidFill>
-                  <a:srgbClr val="B83A24"/>
-                </a:solidFill>
-                <a:latin typeface="Georgia"/>
+              <a:defRPr sz="800" b="0">
+                <a:solidFill>
+                  <a:srgbClr val="CBD5E1"/>
+                </a:solidFill>
+                <a:latin typeface="Segoe UI"/>
               </a:defRPr>
             </a:pPr>
             <a:r>
-              <a:t>Legacy forensic tools (Cellebrite, EnCase) cost ₹25–40L/year, impose 7–30 days lab delay, lack autonomous AI copilot assistance, and have zero real-time GIS patrol mesh integration for emergency dispatch.</a:t>
+              <a:t>Legacy forensic tools lack standardized multi-vendor extraction, corrupt video frames, cost ₹25–40L/year, and offer zero autonomous AI voice assistance for on-scene officers during active raids.</a:t>
             </a:r>
           </a:p>
         </p:txBody>
@@ -8555,27 +8539,28 @@
               <a:spcAft>
                 <a:spcPts val="0"/>
               </a:spcAft>
+              <a:defRPr sz="800" b="0">
+                <a:solidFill>
+                  <a:srgbClr val="CBD5E1"/>
+                </a:solidFill>
+                <a:latin typeface="Segoe UI"/>
+              </a:defRPr>
             </a:pPr>
             <a:r>
-              <a:rPr sz="850" b="1">
-                <a:solidFill>
-                  <a:srgbClr val="6A3D7D"/>
-                </a:solidFill>
-                <a:latin typeface="Georgia"/>
-              </a:rPr>
-              <a:t>Scale Of The Problem :</a:t>
+              <a:t>Scale Of The Problem:</a:t>
             </a:r>
           </a:p>
           <a:p>
-            <a:pPr/>
+            <a:pPr>
+              <a:defRPr sz="800" b="0">
+                <a:solidFill>
+                  <a:srgbClr val="CBD5E1"/>
+                </a:solidFill>
+                <a:latin typeface="Segoe UI"/>
+              </a:defRPr>
+            </a:pPr>
             <a:r>
-              <a:rPr sz="750" b="0">
-                <a:solidFill>
-                  <a:srgbClr val="2C3E50"/>
-                </a:solidFill>
-                <a:latin typeface="Georgia"/>
-              </a:rPr>
-              <a:t>Affects 16,000+ police stations, state cyber cells, NIA, NCB, and Dial 112 emergency patrol units dealing with cross-border syndicates nationwide.</a:t>
+              <a:t>Affects 16,000+ police stations, state cyber crime cells, NIA, NCB, and central intelligence agencies analyzing thousands of crime-scene CCTV hard drives nationwide.</a:t>
             </a:r>
           </a:p>
         </p:txBody>
@@ -8658,27 +8643,28 @@
               <a:spcAft>
                 <a:spcPts val="0"/>
               </a:spcAft>
+              <a:defRPr sz="800" b="0">
+                <a:solidFill>
+                  <a:srgbClr val="CBD5E1"/>
+                </a:solidFill>
+                <a:latin typeface="Segoe UI"/>
+              </a:defRPr>
             </a:pPr>
             <a:r>
-              <a:rPr sz="850" b="1">
-                <a:solidFill>
-                  <a:srgbClr val="1B5278"/>
-                </a:solidFill>
-                <a:latin typeface="Georgia"/>
-              </a:rPr>
-              <a:t>Consequence If Unsolved :</a:t>
+              <a:t>Consequence If Unsolved:</a:t>
             </a:r>
           </a:p>
           <a:p>
-            <a:pPr/>
+            <a:pPr>
+              <a:defRPr sz="800" b="0">
+                <a:solidFill>
+                  <a:srgbClr val="CBD5E1"/>
+                </a:solidFill>
+                <a:latin typeface="Segoe UI"/>
+              </a:defRPr>
+            </a:pPr>
             <a:r>
-              <a:rPr sz="750" b="0">
-                <a:solidFill>
-                  <a:srgbClr val="2C3E50"/>
-                </a:solidFill>
-                <a:latin typeface="Georgia"/>
-              </a:rPr>
-              <a:t>Delayed kingpin identification, fragmented evidence chains, financial hawala channels escaping detection, and fugitive escapes during active investigations.</a:t>
+              <a:t>Inadmissible electronic video evidence, lost deleted footage from overwritten DVR sectors, delayed suspect identification, and fugitives escaping justice.</a:t>
             </a:r>
           </a:p>
         </p:txBody>
@@ -8721,18 +8707,15 @@
               <a:buSzPts val="1200"/>
               <a:buFont typeface="Cambria"/>
               <a:buNone/>
+              <a:defRPr sz="800" b="0">
+                <a:solidFill>
+                  <a:srgbClr val="CBD5E1"/>
+                </a:solidFill>
+                <a:latin typeface="Segoe UI"/>
+              </a:defRPr>
             </a:pPr>
             <a:r>
-              <a:rPr lang="en" sz="1200" b="1" i="0" u="none" strike="noStrike" cap="none" dirty="0">
-                <a:solidFill>
-                  <a:srgbClr val="196F3D"/>
-                </a:solidFill>
-                <a:latin typeface="Times New Roman" panose="02020603050405020304" pitchFamily="18" charset="0"/>
-                <a:ea typeface="Cambria"/>
-                <a:cs typeface="Times New Roman" panose="02020603050405020304" pitchFamily="18" charset="0"/>
-                <a:sym typeface="Cambria"/>
-              </a:rPr>
-              <a:t>Our Solution</a:t>
+              <a:t>Our Solution — SIH26150 Architecture</a:t>
             </a:r>
             <a:endParaRPr sz="1200" b="0" i="0" u="none" strike="noStrike" cap="none" dirty="0">
               <a:solidFill>
@@ -8811,94 +8794,13 @@
           </a:bodyPr>
           <a:lstStyle/>
           <a:p>
-            <a:pPr>
-              <a:defRPr sz="900" b="1">
-                <a:solidFill>
-                  <a:srgbClr val="154360"/>
-                </a:solidFill>
-                <a:latin typeface="Times New Roman"/>
-              </a:defRPr>
-            </a:pPr>
             <a:r>
-              <a:t>Concept Diagram — NCIS Unified Dual Architecture</a:t>
-            </a:r>
-          </a:p>
-        </p:txBody>
-      </p:sp>
-      <p:sp>
-        <p:nvSpPr>
-          <p:cNvPr id="99" name="Google Shape;99;p16"/>
-          <p:cNvSpPr txBox="1"/>
-          <p:nvPr/>
-        </p:nvSpPr>
-        <p:spPr>
-          <a:xfrm>
-            <a:off x="3154680" y="1577340"/>
-            <a:ext cx="2366010" cy="411480"/>
-          </a:xfrm>
-          <a:prstGeom prst="rect">
-            <a:avLst/>
-          </a:prstGeom>
-          <a:noFill/>
-          <a:ln>
-            <a:noFill/>
-          </a:ln>
-        </p:spPr>
-        <p:txBody>
-          <a:bodyPr spcFirstLastPara="1" wrap="square" lIns="0" tIns="0" rIns="0" bIns="0" anchor="ctr" anchorCtr="0">
-            <a:noAutofit/>
-          </a:bodyPr>
-          <a:lstStyle/>
-          <a:p>
-            <a:pPr>
-              <a:defRPr sz="800" b="1">
-                <a:solidFill>
-                  <a:srgbClr val="1B4353"/>
-                </a:solidFill>
-                <a:latin typeface="Georgia"/>
-              </a:defRPr>
-            </a:pPr>
-            <a:r>
-              <a:t>NCIS-TACTICAL: 6 Operational Modules + Case Copilot Voice AI + Tactical Hardware</a:t>
-            </a:r>
-          </a:p>
-        </p:txBody>
-      </p:sp>
-      <p:sp>
-        <p:nvSpPr>
-          <p:cNvPr id="100" name="Google Shape;100;p16"/>
-          <p:cNvSpPr txBox="1"/>
-          <p:nvPr/>
-        </p:nvSpPr>
-        <p:spPr>
-          <a:xfrm>
-            <a:off x="3154680" y="2057400"/>
-            <a:ext cx="2366010" cy="342900"/>
-          </a:xfrm>
-          <a:prstGeom prst="rect">
-            <a:avLst/>
-          </a:prstGeom>
-          <a:noFill/>
-          <a:ln>
-            <a:noFill/>
-          </a:ln>
-        </p:spPr>
-        <p:txBody>
-          <a:bodyPr spcFirstLastPara="1" wrap="square" lIns="0" tIns="0" rIns="0" bIns="0" anchor="b" anchorCtr="0">
-            <a:noAutofit/>
-          </a:bodyPr>
-          <a:lstStyle/>
-          <a:p>
-            <a:pPr>
-              <a:defRPr sz="700" b="1">
-                <a:solidFill>
-                  <a:srgbClr val="1B4353"/>
-                </a:solidFill>
-                <a:latin typeface="Georgia"/>
-              </a:defRPr>
-            </a:pPr>
-            <a:r>
-              <a:t>6 OPERATIONAL MODULES (CORE) + CASE COPILOT AGENTIC VOICE AI + TACTICAL HARDWARE</a:t>
+              <a:rPr sz="850" b="1">
+                <a:solidFill>
+                  <a:srgbClr val="38BDF8"/>
+                </a:solidFill>
+              </a:rPr>
+              <a:t>System Model: Multi-Vendor DVR + Agentic Voice AI</a:t>
             </a:r>
           </a:p>
         </p:txBody>
@@ -8941,17 +8843,14 @@
               <a:buSzPts val="1100"/>
               <a:buFont typeface="Cambria"/>
               <a:buNone/>
+              <a:defRPr sz="800" b="0">
+                <a:solidFill>
+                  <a:srgbClr val="CBD5E1"/>
+                </a:solidFill>
+                <a:latin typeface="Segoe UI"/>
+              </a:defRPr>
             </a:pPr>
             <a:r>
-              <a:rPr lang="en" sz="1100" b="1" i="0" u="none" strike="noStrike" cap="none" dirty="0">
-                <a:solidFill>
-                  <a:srgbClr val="CA6F1E"/>
-                </a:solidFill>
-                <a:latin typeface="Times New Roman" panose="02020603050405020304" pitchFamily="18" charset="0"/>
-                <a:ea typeface="Cambria"/>
-                <a:cs typeface="Times New Roman" panose="02020603050405020304" pitchFamily="18" charset="0"/>
-                <a:sym typeface="Cambria"/>
-              </a:rPr>
               <a:t>Why We Stand Out</a:t>
             </a:r>
             <a:endParaRPr sz="1100" b="0" i="0" u="none" strike="noStrike" cap="none" dirty="0">
@@ -9044,41 +8943,41 @@
               <a:spcAft>
                 <a:spcPts val="0"/>
               </a:spcAft>
-              <a:defRPr sz="750" b="1">
-                <a:solidFill>
-                  <a:srgbClr val="187242"/>
-                </a:solidFill>
-                <a:latin typeface="Georgia"/>
+              <a:defRPr sz="800" b="0">
+                <a:solidFill>
+                  <a:srgbClr val="CBD5E1"/>
+                </a:solidFill>
+                <a:latin typeface="Segoe UI"/>
               </a:defRPr>
             </a:pPr>
             <a:r>
-              <a:t>• Differentiator 1 — Unified 6-Module Core &amp; Case Copilot: Fulfills PS 189 with Live Surveillance, Digital Forensics, GNN Syndicate Graph, ERSS Patrol Mesh, Tactical Hardware, and Autonomous Agentic Voice/NLP Copilot.</a:t>
+              <a:t>• Differentiator 1 — Standardized Multi-Vendor DVR Acquisition: Direct raw bitstream extraction supporting Hikvision, Dahua, CP Plus, Honeywell, and Uniview with write-blocker protection and zero timestamp contamination.</a:t>
             </a:r>
           </a:p>
           <a:p>
             <a:pPr>
-              <a:defRPr sz="750" b="1">
-                <a:solidFill>
-                  <a:srgbClr val="187242"/>
-                </a:solidFill>
-                <a:latin typeface="Georgia"/>
+              <a:defRPr sz="800" b="0">
+                <a:solidFill>
+                  <a:srgbClr val="CBD5E1"/>
+                </a:solidFill>
+                <a:latin typeface="Segoe UI"/>
               </a:defRPr>
             </a:pPr>
             <a:r>
-              <a:t>• Differentiator 2 — Siri Voice Agent &amp; Missing Evidence Radar: Siri-style independent voice agent (EN/HI/TA), Web Speech API mic + TTS (≤3 sentences), missing evidence radar, and interactive GIS touch tracking with Haversine dynamic ETA.</a:t>
+              <a:t>• Differentiator 2 — Autonomous Agentic AI Voice Module: Siri-style independent voice agent (EN/HI/TA) with acoustic wave visualizer, spoken brevity (≤3 sentences), and autonomous tool-calling loop (get_fir, extract_entities, rank_suspects).</a:t>
             </a:r>
           </a:p>
           <a:p>
             <a:pPr>
-              <a:defRPr sz="750" b="1">
-                <a:solidFill>
-                  <a:srgbClr val="187242"/>
-                </a:solidFill>
-                <a:latin typeface="Georgia"/>
+              <a:defRPr sz="800" b="0">
+                <a:solidFill>
+                  <a:srgbClr val="CBD5E1"/>
+                </a:solidFill>
+                <a:latin typeface="Segoe UI"/>
               </a:defRPr>
             </a:pPr>
             <a:r>
-              <a:t>• Differentiator 3 — SIH26150 Multi-Vendor DVR &amp; Judicial Seal: Hardware write-blocker bus switch, multi-vendor DVR/NVR extraction (Hikvision, Dahua, CP Plus), and BNS 2023 Sec 63 / BSA Sec 65B SHA-256 court evidence.</a:t>
+              <a:t>• Differentiator 3 — Unstructured Data to Court-Admissible Proof: Bypasses proprietary wrappers to recover deleted H.264/H.265 frames, auto-generating SHA-256 custody certificates under BNS 2023 Sec 63 &amp; BSA Sec 65B.</a:t>
             </a:r>
           </a:p>
         </p:txBody>
@@ -9281,15 +9180,15 @@
               <a:spcAft>
                 <a:spcPts val="0"/>
               </a:spcAft>
-              <a:defRPr sz="850" b="1">
-                <a:solidFill>
-                  <a:srgbClr val="1B4353"/>
-                </a:solidFill>
-                <a:latin typeface="Georgia"/>
+              <a:defRPr sz="800" b="0">
+                <a:solidFill>
+                  <a:srgbClr val="CBD5E1"/>
+                </a:solidFill>
+                <a:latin typeface="Segoe UI"/>
               </a:defRPr>
             </a:pPr>
             <a:r>
-              <a:t>MOD-01: Live Surveillance</a:t>
+              <a:t>MOD-01: Live Surveillance &amp; Video Ingestion</a:t>
             </a:r>
             <a:endParaRPr sz="800" b="0" i="0" u="none" strike="noStrike" cap="none" dirty="0">
               <a:solidFill>
@@ -9303,15 +9202,15 @@
           </a:p>
           <a:p>
             <a:pPr>
-              <a:defRPr sz="850" b="1">
-                <a:solidFill>
-                  <a:srgbClr val="1B4353"/>
-                </a:solidFill>
-                <a:latin typeface="Georgia"/>
+              <a:defRPr sz="800" b="0">
+                <a:solidFill>
+                  <a:srgbClr val="CBD5E1"/>
+                </a:solidFill>
+                <a:latin typeface="Segoe UI"/>
               </a:defRPr>
             </a:pPr>
             <a:r>
-              <a:t>Sub-50ms live camera ingestion, OpenCV face detection, and WebSocket stream</a:t>
+              <a:t>Sub-50ms multi-camera ingestion, OpenCV facial embedding vectors, and real-time telemetry stream</a:t>
             </a:r>
           </a:p>
         </p:txBody>
@@ -9451,15 +9350,15 @@
               <a:spcAft>
                 <a:spcPts val="0"/>
               </a:spcAft>
-              <a:defRPr sz="850" b="1">
-                <a:solidFill>
-                  <a:srgbClr val="1B4353"/>
-                </a:solidFill>
-                <a:latin typeface="Georgia"/>
+              <a:defRPr sz="800" b="0">
+                <a:solidFill>
+                  <a:srgbClr val="CBD5E1"/>
+                </a:solidFill>
+                <a:latin typeface="Segoe UI"/>
               </a:defRPr>
             </a:pPr>
             <a:r>
-              <a:t>MOD-02: Digital Forensics &amp; SIH26150 DVR</a:t>
+              <a:t>MOD-02: Multi-Vendor DVR/NVR Forensics (SIH26150)</a:t>
             </a:r>
             <a:endParaRPr sz="800" b="1" i="0" u="none" strike="noStrike" cap="none" dirty="0">
               <a:solidFill>
@@ -9473,15 +9372,15 @@
           </a:p>
           <a:p>
             <a:pPr>
-              <a:defRPr sz="850" b="1">
-                <a:solidFill>
-                  <a:srgbClr val="1B4353"/>
-                </a:solidFill>
-                <a:latin typeface="Georgia"/>
+              <a:defRPr sz="800" b="0">
+                <a:solidFill>
+                  <a:srgbClr val="CBD5E1"/>
+                </a:solidFill>
+                <a:latin typeface="Segoe UI"/>
               </a:defRPr>
             </a:pPr>
             <a:r>
-              <a:t>131,072 sector carving with Hailo NPU (26 TOPS) &amp; multi-vendor DVR forensics</a:t>
+              <a:t>Standardized acquisition across Hikvision, Dahua, CP Plus, Honeywell, Uniview &amp; 131k sector carving</a:t>
             </a:r>
           </a:p>
         </p:txBody>
@@ -9621,15 +9520,15 @@
               <a:spcAft>
                 <a:spcPts val="0"/>
               </a:spcAft>
-              <a:defRPr sz="850" b="1">
-                <a:solidFill>
-                  <a:srgbClr val="1B4353"/>
-                </a:solidFill>
-                <a:latin typeface="Georgia"/>
+              <a:defRPr sz="800" b="0">
+                <a:solidFill>
+                  <a:srgbClr val="CBD5E1"/>
+                </a:solidFill>
+                <a:latin typeface="Segoe UI"/>
               </a:defRPr>
             </a:pPr>
             <a:r>
-              <a:t>MOD-03: GNN Syndicate Intel</a:t>
+              <a:t>MOD-03: GNN Syndicate Intel &amp; Graph Mapping</a:t>
             </a:r>
             <a:endParaRPr sz="800" b="1" i="0" u="none" strike="noStrike" cap="none" dirty="0">
               <a:solidFill>
@@ -9643,15 +9542,15 @@
           </a:p>
           <a:p>
             <a:pPr>
-              <a:defRPr sz="850" b="1">
-                <a:solidFill>
-                  <a:srgbClr val="1B4353"/>
-                </a:solidFill>
-                <a:latin typeface="Georgia"/>
+              <a:defRPr sz="800" b="0">
+                <a:solidFill>
+                  <a:srgbClr val="CBD5E1"/>
+                </a:solidFill>
+                <a:latin typeface="Segoe UI"/>
               </a:defRPr>
             </a:pPr>
             <a:r>
-              <a:t>Spectral GCN maps syndicate topology with 98.6% precision &amp; Centrality</a:t>
+              <a:t>Spectral GCN maps multi-camera suspect movements with 98.6% link precision &amp; Betweenness Centrality</a:t>
             </a:r>
           </a:p>
         </p:txBody>
@@ -9791,15 +9690,15 @@
               <a:spcAft>
                 <a:spcPts val="0"/>
               </a:spcAft>
-              <a:defRPr sz="850" b="1">
-                <a:solidFill>
-                  <a:srgbClr val="1B4353"/>
-                </a:solidFill>
-                <a:latin typeface="Georgia"/>
+              <a:defRPr sz="800" b="0">
+                <a:solidFill>
+                  <a:srgbClr val="CBD5E1"/>
+                </a:solidFill>
+                <a:latin typeface="Segoe UI"/>
               </a:defRPr>
             </a:pPr>
             <a:r>
-              <a:t>MOD-04: ERSS Patrol Mesh</a:t>
+              <a:t>MOD-04: ERSS Patrol Mesh &amp; GIS Grid</a:t>
             </a:r>
             <a:endParaRPr sz="800" b="1" i="0" u="none" strike="noStrike" cap="none" dirty="0">
               <a:solidFill>
@@ -9813,15 +9712,15 @@
           </a:p>
           <a:p>
             <a:pPr>
-              <a:defRPr sz="850" b="1">
-                <a:solidFill>
-                  <a:srgbClr val="1B4353"/>
-                </a:solidFill>
-                <a:latin typeface="Georgia"/>
+              <a:defRPr sz="800" b="0">
+                <a:solidFill>
+                  <a:srgbClr val="CBD5E1"/>
+                </a:solidFill>
+                <a:latin typeface="Segoe UI"/>
               </a:defRPr>
             </a:pPr>
             <a:r>
-              <a:t>Interactive GIS map with touch tracking, Haversine distance &amp; rapid dispatch</a:t>
+              <a:t>Interactive GIS map with touch tracking, Haversine distance, dynamic ETA &amp; rapid dispatch</a:t>
             </a:r>
           </a:p>
         </p:txBody>
@@ -9961,28 +9860,28 @@
               <a:spcAft>
                 <a:spcPts val="0"/>
               </a:spcAft>
-              <a:defRPr sz="850" b="1">
-                <a:solidFill>
-                  <a:srgbClr val="1B4353"/>
-                </a:solidFill>
-                <a:latin typeface="Georgia"/>
+              <a:defRPr sz="800" b="0">
+                <a:solidFill>
+                  <a:srgbClr val="CBD5E1"/>
+                </a:solidFill>
+                <a:latin typeface="Segoe UI"/>
               </a:defRPr>
             </a:pPr>
             <a:r>
-              <a:t>MOD-05: Tactical Hardware</a:t>
+              <a:t>MOD-05: Tactical Hardware Console</a:t>
             </a:r>
           </a:p>
           <a:p>
             <a:pPr>
-              <a:defRPr sz="850" b="1">
-                <a:solidFill>
-                  <a:srgbClr val="1B4353"/>
-                </a:solidFill>
-                <a:latin typeface="Georgia"/>
+              <a:defRPr sz="800" b="0">
+                <a:solidFill>
+                  <a:srgbClr val="CBD5E1"/>
+                </a:solidFill>
+                <a:latin typeface="Segoe UI"/>
               </a:defRPr>
             </a:pPr>
             <a:r>
-              <a:t>Physical write-blocker locks, multi-bus selector (PCIe/SATA/USB), raw hex dump</a:t>
+              <a:t>Physical write-blocker locks, multi-bus selector (PCIe/SATA/USB), raw hexadecimal bitstream dump</a:t>
             </a:r>
           </a:p>
         </p:txBody>
@@ -10122,15 +10021,15 @@
               <a:spcAft>
                 <a:spcPts val="0"/>
               </a:spcAft>
-              <a:defRPr sz="850" b="1">
-                <a:solidFill>
-                  <a:srgbClr val="1B4353"/>
-                </a:solidFill>
-                <a:latin typeface="Georgia"/>
+              <a:defRPr sz="800" b="0">
+                <a:solidFill>
+                  <a:srgbClr val="CBD5E1"/>
+                </a:solidFill>
+                <a:latin typeface="Segoe UI"/>
               </a:defRPr>
             </a:pPr>
             <a:r>
-              <a:t>MOD-06: Case Copilot Voice AI</a:t>
+              <a:t>MOD-06: Agentic AI Voice Module (Case Copilot)</a:t>
             </a:r>
             <a:endParaRPr sz="800" b="1" i="0" u="none" strike="noStrike" cap="none" dirty="0">
               <a:solidFill>
@@ -10144,15 +10043,15 @@
           </a:p>
           <a:p>
             <a:pPr>
-              <a:defRPr sz="850" b="1">
-                <a:solidFill>
-                  <a:srgbClr val="1B4353"/>
-                </a:solidFill>
-                <a:latin typeface="Georgia"/>
+              <a:defRPr sz="800" b="0">
+                <a:solidFill>
+                  <a:srgbClr val="CBD5E1"/>
+                </a:solidFill>
+                <a:latin typeface="Segoe UI"/>
               </a:defRPr>
             </a:pPr>
             <a:r>
-              <a:t>Siri voice agent, multilingual NLP, auto BNSS 94/107 drafts &amp; 100% 50-case benchmark</a:t>
+              <a:t>Siri voice agent, multilingual NLP, auto BNSS 94/107 drafts &amp; 100% 50-case benchmark accuracy</a:t>
             </a:r>
           </a:p>
         </p:txBody>
@@ -10173,8 +10072,8 @@
         </p:blipFill>
         <p:spPr>
           <a:xfrm>
-            <a:off x="2928366" y="1056133"/>
-            <a:ext cx="2818637" cy="1515613"/>
+            <a:off x="3040000" y="1320000"/>
+            <a:ext cx="2600000" cy="1240000"/>
           </a:xfrm>
           <a:prstGeom prst="rect">
             <a:avLst/>
@@ -10291,41 +10190,14 @@
           </a:bodyPr>
           <a:lstStyle/>
           <a:p>
-            <a:pPr marL="0" marR="0" lvl="0" indent="0" algn="ctr" rtl="0">
-              <a:spcBef>
-                <a:spcPts val="0"/>
-              </a:spcBef>
-              <a:spcAft>
-                <a:spcPts val="0"/>
-              </a:spcAft>
-              <a:buClr>
-                <a:srgbClr val="154360"/>
-              </a:buClr>
-              <a:buSzPts val="1900"/>
-              <a:buFont typeface="Cambria"/>
-              <a:buNone/>
-            </a:pPr>
             <a:r>
-              <a:rPr lang="en" sz="1900" b="1" i="0" u="none" strike="noStrike" cap="none" dirty="0">
-                <a:solidFill>
-                  <a:srgbClr val="154360"/>
-                </a:solidFill>
-                <a:latin typeface="Times New Roman" panose="02020603050405020304" pitchFamily="18" charset="0"/>
-                <a:ea typeface="Cambria"/>
-                <a:cs typeface="Times New Roman" panose="02020603050405020304" pitchFamily="18" charset="0"/>
-                <a:sym typeface="Cambria"/>
+              <a:rPr sz="1300" b="1">
+                <a:solidFill>
+                  <a:srgbClr val="38BDF8"/>
+                </a:solidFill>
               </a:rPr>
-              <a:t>TECHNICAL APPROACH</a:t>
+              <a:t>TECHNICAL APPROACH &amp; PIPELINE (SIH26150 MULTI-VENDOR DVR TO AGENTIC ACTION)</a:t>
             </a:r>
-            <a:endParaRPr sz="1900" b="0" i="0" u="none" strike="noStrike" cap="none" dirty="0">
-              <a:solidFill>
-                <a:schemeClr val="dk1"/>
-              </a:solidFill>
-              <a:latin typeface="Times New Roman" panose="02020603050405020304" pitchFamily="18" charset="0"/>
-              <a:ea typeface="Calibri"/>
-              <a:cs typeface="Times New Roman" panose="02020603050405020304" pitchFamily="18" charset="0"/>
-              <a:sym typeface="Calibri"/>
-            </a:endParaRPr>
           </a:p>
         </p:txBody>
       </p:sp>
@@ -10658,16 +10530,29 @@
           </a:bodyPr>
           <a:lstStyle/>
           <a:p>
-            <a:pPr/>
+            <a:pPr>
+              <a:defRPr sz="800" b="0">
+                <a:solidFill>
+                  <a:srgbClr val="CBD5E1"/>
+                </a:solidFill>
+                <a:latin typeface="Segoe UI"/>
+              </a:defRPr>
+            </a:pPr>
             <a:r>
-              <a:rPr sz="800" b="1">
-                <a:solidFill>
-                  <a:srgbClr val="1B4353"/>
-                </a:solidFill>
-                <a:latin typeface="Georgia"/>
-              </a:rPr>
-              <a:t>Sub-50ms Multi-Source
-Ingestion &amp; OpenCV</a:t>
+              <a:t>1. Multi-Vendor DVR Acquisition</a:t>
+            </a:r>
+          </a:p>
+          <a:p>
+            <a:pPr>
+              <a:defRPr sz="800" b="0">
+                <a:solidFill>
+                  <a:srgbClr val="CBD5E1"/>
+                </a:solidFill>
+                <a:latin typeface="Segoe UI"/>
+              </a:defRPr>
+            </a:pPr>
+            <a:r>
+              <a:t>(Hikvision, Dahua, CP Plus)</a:t>
             </a:r>
           </a:p>
         </p:txBody>
@@ -11113,28 +10998,28 @@
           <a:lstStyle/>
           <a:p>
             <a:pPr>
-              <a:defRPr sz="800" b="1">
-                <a:solidFill>
-                  <a:srgbClr val="1B4353"/>
-                </a:solidFill>
-                <a:latin typeface="Georgia"/>
+              <a:defRPr sz="800" b="0">
+                <a:solidFill>
+                  <a:srgbClr val="CBD5E1"/>
+                </a:solidFill>
+                <a:latin typeface="Segoe UI"/>
               </a:defRPr>
             </a:pPr>
             <a:r>
-              <a:t>Case Copilot Voice &amp;</a:t>
+              <a:t>3. Agentic AI Voice Module</a:t>
             </a:r>
           </a:p>
           <a:p>
             <a:pPr>
-              <a:defRPr sz="800" b="1">
-                <a:solidFill>
-                  <a:srgbClr val="1B4353"/>
-                </a:solidFill>
-                <a:latin typeface="Georgia"/>
+              <a:defRPr sz="800" b="0">
+                <a:solidFill>
+                  <a:srgbClr val="CBD5E1"/>
+                </a:solidFill>
+                <a:latin typeface="Segoe UI"/>
               </a:defRPr>
             </a:pPr>
             <a:r>
-              <a:t>NLP Tool-Calling Engine</a:t>
+              <a:t>&amp; Copilot Reasoning Loop</a:t>
             </a:r>
           </a:p>
         </p:txBody>
@@ -11376,16 +11261,29 @@
           </a:bodyPr>
           <a:lstStyle/>
           <a:p>
-            <a:pPr/>
+            <a:pPr>
+              <a:defRPr sz="800" b="0">
+                <a:solidFill>
+                  <a:srgbClr val="CBD5E1"/>
+                </a:solidFill>
+                <a:latin typeface="Segoe UI"/>
+              </a:defRPr>
+            </a:pPr>
             <a:r>
-              <a:rPr sz="800" b="1">
-                <a:solidFill>
-                  <a:srgbClr val="1B4353"/>
-                </a:solidFill>
-                <a:latin typeface="Georgia"/>
-              </a:rPr>
-              <a:t>Interactive Vector GIS
-&amp; Haversine Tracking</a:t>
+              <a:t>4. Spectral GCN Syndicate</a:t>
+            </a:r>
+          </a:p>
+          <a:p>
+            <a:pPr>
+              <a:defRPr sz="800" b="0">
+                <a:solidFill>
+                  <a:srgbClr val="CBD5E1"/>
+                </a:solidFill>
+                <a:latin typeface="Segoe UI"/>
+              </a:defRPr>
+            </a:pPr>
+            <a:r>
+              <a:t>Topology Engine (98.6%)</a:t>
             </a:r>
           </a:p>
         </p:txBody>
@@ -11627,16 +11525,29 @@
           </a:bodyPr>
           <a:lstStyle/>
           <a:p>
-            <a:pPr/>
+            <a:pPr>
+              <a:defRPr sz="800" b="0">
+                <a:solidFill>
+                  <a:srgbClr val="CBD5E1"/>
+                </a:solidFill>
+                <a:latin typeface="Segoe UI"/>
+              </a:defRPr>
+            </a:pPr>
             <a:r>
-              <a:rPr sz="800" b="1">
-                <a:solidFill>
-                  <a:srgbClr val="1B4353"/>
-                </a:solidFill>
-                <a:latin typeface="Georgia"/>
-              </a:rPr>
-              <a:t>Dual ERSS Patrol Mesh
-&amp; BNS 63 Evidence Seal</a:t>
+              <a:t>5. Dual ERSS Patrol Mesh</a:t>
+            </a:r>
+          </a:p>
+          <a:p>
+            <a:pPr>
+              <a:defRPr sz="800" b="0">
+                <a:solidFill>
+                  <a:srgbClr val="CBD5E1"/>
+                </a:solidFill>
+                <a:latin typeface="Segoe UI"/>
+              </a:defRPr>
+            </a:pPr>
+            <a:r>
+              <a:t>&amp; BNSS 63 Evidence Seal</a:t>
             </a:r>
           </a:p>
         </p:txBody>
@@ -11725,18 +11636,15 @@
               <a:buSzPts val="1000"/>
               <a:buFont typeface="Cambria"/>
               <a:buNone/>
+              <a:defRPr sz="800" b="0">
+                <a:solidFill>
+                  <a:srgbClr val="CBD5E1"/>
+                </a:solidFill>
+                <a:latin typeface="Segoe UI"/>
+              </a:defRPr>
             </a:pPr>
             <a:r>
-              <a:rPr lang="en" sz="1000" b="1" i="0" u="none" strike="noStrike" cap="none" dirty="0">
-                <a:solidFill>
-                  <a:srgbClr val="CA6F1E"/>
-                </a:solidFill>
-                <a:latin typeface="Times New Roman" panose="02020603050405020304" pitchFamily="18" charset="0"/>
-                <a:ea typeface="Cambria"/>
-                <a:cs typeface="Times New Roman" panose="02020603050405020304" pitchFamily="18" charset="0"/>
-                <a:sym typeface="Cambria"/>
-              </a:rPr>
-              <a:t>Tech Stack</a:t>
+              <a:t>Tech Stack &amp; Hardware Bus</a:t>
             </a:r>
             <a:endParaRPr sz="1000" b="0" i="0" u="none" strike="noStrike" cap="none" dirty="0">
               <a:solidFill>
@@ -11782,15 +11690,15 @@
               <a:spcAft>
                 <a:spcPts val="0"/>
               </a:spcAft>
-              <a:defRPr sz="720" b="1">
-                <a:solidFill>
-                  <a:srgbClr val="1B4353"/>
-                </a:solidFill>
-                <a:latin typeface="Georgia"/>
+              <a:defRPr sz="800" b="0">
+                <a:solidFill>
+                  <a:srgbClr val="CBD5E1"/>
+                </a:solidFill>
+                <a:latin typeface="Segoe UI"/>
               </a:defRPr>
             </a:pPr>
             <a:r>
-              <a:t>• Frontend  : React 18, Tailwind CSS, Apple iOS Glassmorphism UI, Web Speech API / TTS, Siri Orb Visualizer, Vector GIS</a:t>
+              <a:t>• Forensics : SIH26150 Multi-Vendor DVR Tool, Hardware Write-Blocker Bus (PCIe NVMe, SATA III, USB 3.2, JTAG)</a:t>
             </a:r>
             <a:endParaRPr sz="800" b="0" i="0" u="none" strike="noStrike" cap="none" dirty="0">
               <a:solidFill>
@@ -11804,41 +11712,41 @@
           </a:p>
           <a:p>
             <a:pPr>
-              <a:defRPr sz="720" b="1">
-                <a:solidFill>
-                  <a:srgbClr val="1B4353"/>
-                </a:solidFill>
-                <a:latin typeface="Georgia"/>
+              <a:defRPr sz="800" b="0">
+                <a:solidFill>
+                  <a:srgbClr val="CBD5E1"/>
+                </a:solidFill>
+                <a:latin typeface="Segoe UI"/>
               </a:defRPr>
             </a:pPr>
             <a:r>
-              <a:t>• Backend   : Python FastAPI, OpenCV Headless, Redis, PostgreSQL, Case Copilot Autonomous Engine</a:t>
+              <a:t>• AI/ML &amp; NLP: Hailo-8L Edge AI (26 TOPS), PyTorch Geometric GCN (98.6%), SpaCy Indian Legal NER</a:t>
             </a:r>
           </a:p>
           <a:p>
             <a:pPr>
-              <a:defRPr sz="720" b="1">
-                <a:solidFill>
-                  <a:srgbClr val="1B4353"/>
-                </a:solidFill>
-                <a:latin typeface="Georgia"/>
+              <a:defRPr sz="800" b="0">
+                <a:solidFill>
+                  <a:srgbClr val="CBD5E1"/>
+                </a:solidFill>
+                <a:latin typeface="Segoe UI"/>
               </a:defRPr>
             </a:pPr>
             <a:r>
-              <a:t>• AI/ML &amp; NLP: PyTorch Geometric GCN (98.6%), Indian Legal NLP NER, Hailo NPU (26 TOPS), Whisper/Web Speech</a:t>
+              <a:t>• Frontend  : React 18, Tailwind CSS, Apple iOS Glassmorphism UI, Web Speech API / TTS, Siri Orb Visualizer</a:t>
             </a:r>
           </a:p>
           <a:p>
             <a:pPr>
-              <a:defRPr sz="720" b="1">
-                <a:solidFill>
-                  <a:srgbClr val="1B4353"/>
-                </a:solidFill>
-                <a:latin typeface="Georgia"/>
+              <a:defRPr sz="800" b="0">
+                <a:solidFill>
+                  <a:srgbClr val="CBD5E1"/>
+                </a:solidFill>
+                <a:latin typeface="Segoe UI"/>
               </a:defRPr>
             </a:pPr>
             <a:r>
-              <a:t>• Forensics : SIH26150 DVR/NVR Tool, Tactical Write-Blocker Bus (PCIe NVMe, SATA III, USB 3.2, JTAG)</a:t>
+              <a:t>• Backend   : Python FastAPI async, OpenCV Headless, Redis Pub/Sub, PostgreSQL 15 (Air-gapped capability)</a:t>
             </a:r>
           </a:p>
         </p:txBody>
@@ -11927,18 +11835,15 @@
               <a:buSzPts val="1000"/>
               <a:buFont typeface="Cambria"/>
               <a:buNone/>
+              <a:defRPr sz="800" b="0">
+                <a:solidFill>
+                  <a:srgbClr val="CBD5E1"/>
+                </a:solidFill>
+                <a:latin typeface="Segoe UI"/>
+              </a:defRPr>
             </a:pPr>
             <a:r>
-              <a:rPr lang="en" sz="1000" b="1" i="0" u="none" strike="noStrike" cap="none">
-                <a:solidFill>
-                  <a:srgbClr val="1F618D"/>
-                </a:solidFill>
-                <a:latin typeface="Cambria"/>
-                <a:ea typeface="Cambria"/>
-                <a:cs typeface="Cambria"/>
-                <a:sym typeface="Cambria"/>
-              </a:rPr>
-              <a:t>Connectivity &amp; Security</a:t>
+              <a:t>Unstructured Video &amp; Agentic AI</a:t>
             </a:r>
             <a:endParaRPr sz="1000" b="0" i="0" u="none" strike="noStrike" cap="none">
               <a:solidFill>
@@ -11984,15 +11889,15 @@
               <a:spcAft>
                 <a:spcPts val="0"/>
               </a:spcAft>
-              <a:defRPr sz="720" b="1">
-                <a:solidFill>
-                  <a:srgbClr val="1B4353"/>
-                </a:solidFill>
-                <a:latin typeface="Georgia"/>
+              <a:defRPr sz="800" b="0">
+                <a:solidFill>
+                  <a:srgbClr val="CBD5E1"/>
+                </a:solidFill>
+                <a:latin typeface="Segoe UI"/>
               </a:defRPr>
             </a:pPr>
             <a:r>
-              <a:t>• Network  : Cloud server real-time deployment + 100% offline air-gapped field capability</a:t>
+              <a:t>• Video Parsing: Bypasses proprietary DVR containers (DHFS, HIK, WFS) extracting native H.264/H.265 frames in &lt;180s</a:t>
             </a:r>
             <a:endParaRPr lang="en" sz="800" b="0" i="0" u="none" strike="noStrike" cap="none" dirty="0">
               <a:solidFill>
@@ -12006,41 +11911,41 @@
           </a:p>
           <a:p>
             <a:pPr>
-              <a:defRPr sz="720" b="1">
-                <a:solidFill>
-                  <a:srgbClr val="1B4353"/>
-                </a:solidFill>
-                <a:latin typeface="Georgia"/>
+              <a:defRPr sz="800" b="0">
+                <a:solidFill>
+                  <a:srgbClr val="CBD5E1"/>
+                </a:solidFill>
+                <a:latin typeface="Segoe UI"/>
               </a:defRPr>
             </a:pPr>
             <a:r>
-              <a:t>• Cloud    : Encrypted telemetry sync with CCTNS 2.0, ICJS, and NATGRID control rooms</a:t>
+              <a:t>• Voice Agent  : Siri Voice Orb Visualizer with dynamic acoustic waves; multilingual recognition (EN, HI, TA)</a:t>
             </a:r>
           </a:p>
           <a:p>
             <a:pPr>
-              <a:defRPr sz="720" b="1">
-                <a:solidFill>
-                  <a:srgbClr val="1B4353"/>
-                </a:solidFill>
-                <a:latin typeface="Georgia"/>
+              <a:defRPr sz="800" b="0">
+                <a:solidFill>
+                  <a:srgbClr val="CBD5E1"/>
+                </a:solidFill>
+                <a:latin typeface="Segoe UI"/>
               </a:defRPr>
             </a:pPr>
             <a:r>
-              <a:t>• Security : MHA Root CA verification, FIPS 140-3 handshake, BNS Sec 63 &amp; BSA Sec 65B SHA-256 seal, DPDP 2023 vectors</a:t>
+              <a:t>• Brevity      : Spoken responses strictly capped at ≤3 sentences for tactical radio brevity</a:t>
             </a:r>
           </a:p>
           <a:p>
             <a:pPr>
-              <a:defRPr sz="720" b="1">
-                <a:solidFill>
-                  <a:srgbClr val="1B4353"/>
-                </a:solidFill>
-                <a:latin typeface="Georgia"/>
+              <a:defRPr sz="800" b="0">
+                <a:solidFill>
+                  <a:srgbClr val="CBD5E1"/>
+                </a:solidFill>
+                <a:latin typeface="Segoe UI"/>
               </a:defRPr>
             </a:pPr>
             <a:r>
-              <a:t>• Legal AI  : Automated statutory drafting under BNSS 2023 Sec 94 (CDR), Sec 107 (Bank Freeze), Sec 176 (Search)</a:t>
+              <a:t>• Legal Engine : Autonomous tool loop generating BNSS 2023 Sec 94 (CDR), Sec 107 (Freeze) requisitions in 5s</a:t>
             </a:r>
           </a:p>
         </p:txBody>
@@ -12129,18 +12034,15 @@
               <a:buSzPts val="1000"/>
               <a:buFont typeface="Cambria"/>
               <a:buNone/>
+              <a:defRPr sz="800" b="0">
+                <a:solidFill>
+                  <a:srgbClr val="CBD5E1"/>
+                </a:solidFill>
+                <a:latin typeface="Segoe UI"/>
+              </a:defRPr>
             </a:pPr>
             <a:r>
-              <a:rPr lang="en" sz="1000" b="1" i="0" u="none" strike="noStrike" cap="none">
-                <a:solidFill>
-                  <a:srgbClr val="196F3D"/>
-                </a:solidFill>
-                <a:latin typeface="Cambria"/>
-                <a:ea typeface="Cambria"/>
-                <a:cs typeface="Cambria"/>
-                <a:sym typeface="Cambria"/>
-              </a:rPr>
-              <a:t>Product Status</a:t>
+              <a:t>Production Status &amp; 50-Case Eval</a:t>
             </a:r>
             <a:endParaRPr sz="1000" b="0" i="0" u="none" strike="noStrike" cap="none">
               <a:solidFill>
@@ -12186,11 +12088,11 @@
               <a:spcAft>
                 <a:spcPts val="0"/>
               </a:spcAft>
-              <a:defRPr sz="720" b="1">
-                <a:solidFill>
-                  <a:srgbClr val="187242"/>
-                </a:solidFill>
-                <a:latin typeface="Georgia"/>
+              <a:defRPr sz="800" b="0">
+                <a:solidFill>
+                  <a:srgbClr val="CBD5E1"/>
+                </a:solidFill>
+                <a:latin typeface="Segoe UI"/>
               </a:defRPr>
             </a:pPr>
             <a:r>
@@ -12208,11 +12110,11 @@
           </a:p>
           <a:p>
             <a:pPr>
-              <a:defRPr sz="720" b="1">
-                <a:solidFill>
-                  <a:srgbClr val="187242"/>
-                </a:solidFill>
-                <a:latin typeface="Georgia"/>
+              <a:defRPr sz="800" b="0">
+                <a:solidFill>
+                  <a:srgbClr val="CBD5E1"/>
+                </a:solidFill>
+                <a:latin typeface="Segoe UI"/>
               </a:defRPr>
             </a:pPr>
             <a:r>
@@ -12221,17 +12123,30 @@
           </a:p>
           <a:p>
             <a:pPr>
-              <a:defRPr sz="720" b="1">
-                <a:solidFill>
-                  <a:srgbClr val="187242"/>
-                </a:solidFill>
-                <a:latin typeface="Georgia"/>
+              <a:defRPr sz="800" b="0">
+                <a:solidFill>
+                  <a:srgbClr val="CBD5E1"/>
+                </a:solidFill>
+                <a:latin typeface="Segoe UI"/>
               </a:defRPr>
             </a:pPr>
             <a:r>
               <a:t>• Live   : Deployed at cyber-kit-police.vercel.app (Publicly Accessible)</a:t>
             </a:r>
           </a:p>
+          <a:p>
+            <a:pPr>
+              <a:defRPr sz="800" b="0">
+                <a:solidFill>
+                  <a:srgbClr val="CBD5E1"/>
+                </a:solidFill>
+                <a:latin typeface="Segoe UI"/>
+              </a:defRPr>
+            </a:pPr>
+            <a:r>
+              <a:t>• Eval   : 100% Entity F1, 100% Kingpin Top-3, 100% Evidence Gap Recall across 50 Synthetic FIR Cases</a:t>
+            </a:r>
+          </a:p>
         </p:txBody>
       </p:sp>
       <p:sp>
@@ -12259,104 +12174,9 @@
           </a:bodyPr>
           <a:lstStyle/>
           <a:p>
-            <a:pPr marL="0" marR="0" lvl="0" indent="0" algn="ctr" rtl="0">
-              <a:spcBef>
-                <a:spcPts val="0"/>
-              </a:spcBef>
-              <a:spcAft>
-                <a:spcPts val="0"/>
-              </a:spcAft>
-              <a:buClr>
-                <a:srgbClr val="154360"/>
-              </a:buClr>
-              <a:buSzPts val="1000"/>
-              <a:buFont typeface="Cambria"/>
-              <a:buNone/>
-            </a:pPr>
             <a:r>
-              <a:rPr lang="en" sz="1000" b="1" i="0" u="none" strike="noStrike" cap="none">
-                <a:solidFill>
-                  <a:srgbClr val="154360"/>
-                </a:solidFill>
-                <a:latin typeface="Cambria"/>
-                <a:ea typeface="Cambria"/>
-                <a:cs typeface="Cambria"/>
-                <a:sym typeface="Cambria"/>
-              </a:rPr>
-              <a:t>Working Prototype — Live Monitoring / Demo</a:t>
+              <a:t>Operational Platform: Live Interface + Agentic AI Voice Module &amp; Benchmark</a:t>
             </a:r>
-            <a:endParaRPr sz="1000" b="0" i="0" u="none" strike="noStrike" cap="none">
-              <a:solidFill>
-                <a:schemeClr val="dk1"/>
-              </a:solidFill>
-              <a:latin typeface="Calibri"/>
-              <a:ea typeface="Calibri"/>
-              <a:cs typeface="Calibri"/>
-              <a:sym typeface="Calibri"/>
-            </a:endParaRPr>
-          </a:p>
-        </p:txBody>
-      </p:sp>
-      <p:sp>
-        <p:nvSpPr>
-          <p:cNvPr id="172" name="Google Shape;172;p17"/>
-          <p:cNvSpPr txBox="1"/>
-          <p:nvPr/>
-        </p:nvSpPr>
-        <p:spPr>
-          <a:xfrm>
-            <a:off x="274320" y="3566160"/>
-            <a:ext cx="1645920" cy="1234440"/>
-          </a:xfrm>
-          <a:prstGeom prst="rect">
-            <a:avLst/>
-          </a:prstGeom>
-          <a:noFill/>
-          <a:ln>
-            <a:noFill/>
-          </a:ln>
-        </p:spPr>
-        <p:txBody>
-          <a:bodyPr spcFirstLastPara="1" wrap="square" lIns="0" tIns="0" rIns="0" bIns="0" anchor="ctr" anchorCtr="0">
-            <a:noAutofit/>
-          </a:bodyPr>
-          <a:lstStyle/>
-          <a:p>
-            <a:pPr marL="0" marR="0" lvl="0" indent="0" algn="ctr" rtl="0">
-              <a:spcBef>
-                <a:spcPts val="0"/>
-              </a:spcBef>
-              <a:spcAft>
-                <a:spcPts val="0"/>
-              </a:spcAft>
-              <a:buClr>
-                <a:srgbClr val="707B7C"/>
-              </a:buClr>
-              <a:buSzPts val="700"/>
-              <a:buFont typeface="Calibri"/>
-              <a:buNone/>
-            </a:pPr>
-            <a:r>
-              <a:rPr lang="en" sz="700" b="0" i="1" u="none" strike="noStrike" cap="none">
-                <a:solidFill>
-                  <a:srgbClr val="707B7C"/>
-                </a:solidFill>
-                <a:latin typeface="Calibri"/>
-                <a:ea typeface="Calibri"/>
-                <a:cs typeface="Calibri"/>
-                <a:sym typeface="Calibri"/>
-              </a:rPr>
-              <a:t>[ Prototype photo / dashboard screenshot ]</a:t>
-            </a:r>
-            <a:endParaRPr sz="700" b="0" i="0" u="none" strike="noStrike" cap="none">
-              <a:solidFill>
-                <a:schemeClr val="dk1"/>
-              </a:solidFill>
-              <a:latin typeface="Calibri"/>
-              <a:ea typeface="Calibri"/>
-              <a:cs typeface="Calibri"/>
-              <a:sym typeface="Calibri"/>
-            </a:endParaRPr>
           </a:p>
         </p:txBody>
       </p:sp>
@@ -12425,185 +12245,96 @@
           <a:noFill/>
         </p:spPr>
         <p:txBody>
-          <a:bodyPr wrap="square">
+          <a:bodyPr wrap="square" tIns="73152">
             <a:spAutoFit/>
           </a:bodyPr>
           <a:lstStyle/>
           <a:p>
             <a:pPr>
-              <a:defRPr sz="800" b="1">
-                <a:solidFill>
-                  <a:srgbClr val="1B4353"/>
+              <a:defRPr sz="850" b="1">
+                <a:solidFill>
+                  <a:srgbClr val="38BDF8"/>
                 </a:solidFill>
                 <a:latin typeface="Georgia"/>
               </a:defRPr>
             </a:pPr>
             <a:r>
-              <a:t>Live Working Production Platform &amp; SIH 189 Highlights:</a:t>
+              <a:t>AGENTIC AI VOICE MODULE &amp; SIH26150 PRODUCTION HIGHLIGHTS:</a:t>
             </a:r>
           </a:p>
           <a:p>
             <a:pPr>
-              <a:defRPr sz="800" b="1">
-                <a:solidFill>
-                  <a:srgbClr val="1B4353"/>
-                </a:solidFill>
-                <a:latin typeface="Georgia"/>
+              <a:spcBef>
+                <a:spcPts val="150"/>
+              </a:spcBef>
+              <a:defRPr sz="750">
+                <a:solidFill>
+                  <a:srgbClr val="CBD5E1"/>
+                </a:solidFill>
               </a:defRPr>
             </a:pPr>
             <a:r>
-              <a:t>• Case Copilot Agentic Voice: Independent Siri voice agent (EN/HI/TA) with 100% accuracy on 50 synthetic FIR cases.</a:t>
+              <a:t>• SIH26150 DVR Core: Standardized CCTV evidence recovery across Hikvision, Dahua, CP Plus, Honeywell, Uniview.</a:t>
             </a:r>
           </a:p>
           <a:p>
             <a:pPr>
-              <a:defRPr sz="800" b="1">
-                <a:solidFill>
-                  <a:srgbClr val="1B4353"/>
-                </a:solidFill>
-                <a:latin typeface="Georgia"/>
+              <a:spcBef>
+                <a:spcPts val="150"/>
+              </a:spcBef>
+              <a:defRPr sz="750">
+                <a:solidFill>
+                  <a:srgbClr val="CBD5E1"/>
+                </a:solidFill>
               </a:defRPr>
             </a:pPr>
             <a:r>
-              <a:t>• Spectral GCN Topology: 98.6% link precision with Betweenness Centrality kingpin ranking.</a:t>
+              <a:t>• Agentic Voice Loop: Siri-style glowing orb with dynamic soundwaves; spoken replies ≤3 sentences (EN/HI/TA).</a:t>
             </a:r>
           </a:p>
           <a:p>
             <a:pPr>
-              <a:defRPr sz="800" b="1">
-                <a:solidFill>
-                  <a:srgbClr val="1B4353"/>
-                </a:solidFill>
-                <a:latin typeface="Georgia"/>
+              <a:spcBef>
+                <a:spcPts val="150"/>
+              </a:spcBef>
+              <a:defRPr sz="750">
+                <a:solidFill>
+                  <a:srgbClr val="CBD5E1"/>
+                </a:solidFill>
               </a:defRPr>
             </a:pPr>
             <a:r>
-              <a:t>• Modern iOS Glass UI: Apple iOS frosted glass theme, 3-bar collapsible sidebar toggle &amp; glowing Siri orb trigger.</a:t>
+              <a:t>• Autonomous Tools: Auto-executes get_fir → extract_entities → rank_suspects → list_evidence_gaps.</a:t>
             </a:r>
           </a:p>
           <a:p>
             <a:pPr>
-              <a:defRPr sz="800" b="1">
-                <a:solidFill>
-                  <a:srgbClr val="1B4353"/>
-                </a:solidFill>
-                <a:latin typeface="Georgia"/>
+              <a:spcBef>
+                <a:spcPts val="150"/>
+              </a:spcBef>
+              <a:defRPr sz="750">
+                <a:solidFill>
+                  <a:srgbClr val="CBD5E1"/>
+                </a:solidFill>
               </a:defRPr>
             </a:pPr>
             <a:r>
-              <a:t>• Tactical Hardware &amp; SIH26150: Physical write-blocker bus switch with raw bitstream hex dump &amp; multi-vendor DVR engine.</a:t>
+              <a:t>• Missing Evidence Radar: Flags pending CCTV footage, CDRs, bank freezes; drafts BNSS 94/107/176 notices in 5s.</a:t>
             </a:r>
           </a:p>
-        </p:txBody>
-      </p:sp>
-      <p:pic>
-        <p:nvPicPr>
-          <p:cNvPr id="188" name="Picture 187" descr="image.jpg"/>
-          <p:cNvPicPr>
-            <a:picLocks noChangeAspect="1"/>
-          </p:cNvPicPr>
-          <p:nvPr/>
-        </p:nvPicPr>
-        <p:blipFill>
-          <a:blip r:embed="rId6"/>
-          <a:stretch>
-            <a:fillRect/>
-          </a:stretch>
-        </p:blipFill>
-        <p:spPr>
-          <a:xfrm>
-            <a:off x="210312" y="3520440"/>
-            <a:ext cx="4114800" cy="1298448"/>
-          </a:xfrm>
-          <a:prstGeom prst="rect">
-            <a:avLst/>
-          </a:prstGeom>
-        </p:spPr>
-      </p:pic>
-      <p:sp>
-        <p:nvSpPr>
-          <p:cNvPr id="189" name="TextBox 188"/>
-          <p:cNvSpPr txBox="1"/>
-          <p:nvPr/>
-        </p:nvSpPr>
-        <p:spPr>
-          <a:xfrm>
-            <a:off x="4480560" y="3520440"/>
-            <a:ext cx="4434840" cy="1298448"/>
-          </a:xfrm>
-          <a:prstGeom prst="rect">
-            <a:avLst/>
-          </a:prstGeom>
-          <a:noFill/>
-        </p:spPr>
-        <p:txBody>
-          <a:bodyPr wrap="square">
-            <a:spAutoFit/>
-          </a:bodyPr>
-          <a:lstStyle/>
           <a:p>
             <a:pPr>
-              <a:defRPr sz="800" b="1">
-                <a:solidFill>
-                  <a:srgbClr val="1B4353"/>
-                </a:solidFill>
-                <a:latin typeface="Georgia"/>
+              <a:spcBef>
+                <a:spcPts val="150"/>
+              </a:spcBef>
+              <a:defRPr sz="750">
+                <a:solidFill>
+                  <a:srgbClr val="CBD5E1"/>
+                </a:solidFill>
               </a:defRPr>
             </a:pPr>
             <a:r>
-              <a:t>Live Working Production Platform &amp; SIH 189 Highlights:</a:t>
-            </a:r>
-          </a:p>
-          <a:p>
-            <a:pPr>
-              <a:defRPr sz="800" b="1">
-                <a:solidFill>
-                  <a:srgbClr val="1B4353"/>
-                </a:solidFill>
-                <a:latin typeface="Georgia"/>
-              </a:defRPr>
-            </a:pPr>
-            <a:r>
-              <a:t>• Case Copilot Agentic Voice: Independent Siri voice agent (EN/HI/TA) with 100% accuracy on 50 synthetic FIR cases.</a:t>
-            </a:r>
-          </a:p>
-          <a:p>
-            <a:pPr>
-              <a:defRPr sz="800" b="1">
-                <a:solidFill>
-                  <a:srgbClr val="1B4353"/>
-                </a:solidFill>
-                <a:latin typeface="Georgia"/>
-              </a:defRPr>
-            </a:pPr>
-            <a:r>
-              <a:t>• Spectral GCN Topology: 98.6% link precision with Betweenness Centrality kingpin ranking.</a:t>
-            </a:r>
-          </a:p>
-          <a:p>
-            <a:pPr>
-              <a:defRPr sz="800" b="1">
-                <a:solidFill>
-                  <a:srgbClr val="1B4353"/>
-                </a:solidFill>
-                <a:latin typeface="Georgia"/>
-              </a:defRPr>
-            </a:pPr>
-            <a:r>
-              <a:t>• Modern iOS Glass UI: Apple iOS frosted glass theme, 3-bar collapsible sidebar toggle &amp; glowing Siri orb trigger.</a:t>
-            </a:r>
-          </a:p>
-          <a:p>
-            <a:pPr>
-              <a:defRPr sz="800" b="1">
-                <a:solidFill>
-                  <a:srgbClr val="1B4353"/>
-                </a:solidFill>
-                <a:latin typeface="Georgia"/>
-              </a:defRPr>
-            </a:pPr>
-            <a:r>
-              <a:t>• Tactical Hardware &amp; SIH26150: Physical write-blocker bus switch with raw bitstream hex dump &amp; multi-vendor DVR engine.</a:t>
+              <a:t>• 50-Case Evaluation: 100% Entity F1, 100% Kingpin Top-3, 100% Evidence Gap Recall on ground-truth benchmark.</a:t>
             </a:r>
           </a:p>
         </p:txBody>
@@ -12630,16 +12361,29 @@
           </a:bodyPr>
           <a:lstStyle/>
           <a:p>
-            <a:pPr/>
+            <a:pPr>
+              <a:defRPr sz="800" b="1">
+                <a:solidFill>
+                  <a:srgbClr val="1B4353"/>
+                </a:solidFill>
+                <a:latin typeface="Segoe UI"/>
+              </a:defRPr>
+            </a:pPr>
             <a:r>
-              <a:rPr sz="800" b="1">
+              <a:t>2. NLP Entity Extraction</a:t>
+            </a:r>
+          </a:p>
+          <a:p>
+            <a:pPr>
+              <a:defRPr sz="800" b="1">
                 <a:solidFill>
                   <a:srgbClr val="1B4353"/>
                 </a:solidFill>
-                <a:latin typeface="Georgia"/>
-              </a:rPr>
-              <a:t>Spectral GCN Syndicate
-Topology Engine</a:t>
+                <a:latin typeface="Segoe UI"/>
+              </a:defRPr>
+            </a:pPr>
+            <a:r>
+              <a:t>&amp; 128D Face Vectors</a:t>
             </a:r>
           </a:p>
         </p:txBody>
@@ -13096,7 +12840,7 @@
               </a:defRPr>
             </a:pPr>
             <a:r>
-              <a:t>• Skills Available: PyTorch Geometric, FastAPI, Web Speech API, React 18, Hailo NPU, Hardware Bus &amp; DVR Protocols.</a:t>
+              <a:t>• Skills Available: SIH26150 multi-vendor DVR parser, PyTorch Geometric, FastAPI, Web Speech API, React 18, Hailo NPU, Hardware Bus.</a:t>
             </a:r>
           </a:p>
           <a:p>
@@ -14461,7 +14205,7 @@
               </a:defRPr>
             </a:pPr>
             <a:r>
-              <a:t>• Software Payback: Immediate; replaces expensive multi-lakh yearly proprietary licenses (Cellebrite, i2).</a:t>
+              <a:t>• Software Payback: Slashes CCTV forensic triage from 7–30 days to &lt;180 seconds, replacing expensive ₹25L–40L proprietary lab software.</a:t>
             </a:r>
           </a:p>
           <a:p>
@@ -15717,7 +15461,7 @@
               </a:defRPr>
             </a:pPr>
             <a:r>
-              <a:t>Target Beneficiaries : State Police Departments, Cyber Crime Units, NIA, NCB, Border Checkpoints, 16,000+ police stations &amp; Dial 112 emergency patrol units nationwide.</a:t>
+              <a:t>Target Beneficiaries : State Police Departments, Cyber Crime Units, NIA, NCB, Forensic Science Laboratories (FSLs), 16,000+ police stations &amp; Dial 112 units nationwide.</a:t>
             </a:r>
           </a:p>
         </p:txBody>
@@ -15903,7 +15647,11 @@
               </a:defRPr>
             </a:pPr>
             <a:r>
-              <a:t>Faster network discovery</a:t>
+              <a:t>Faster DVR triage &amp; AI discovery</a:t>
+            </a:r>
+            <a:br/>
+            <a:r>
+              <a:t>(&lt;180s on-scene vs 30-day lab backlog)</a:t>
             </a:r>
           </a:p>
           <a:p>
@@ -17686,17 +17434,17 @@
                 <a:spcPts val="0"/>
               </a:spcBef>
               <a:spcAft>
-                <a:spcPts val="0"/>
-              </a:spcAft>
-              <a:defRPr sz="750" b="0">
-                <a:solidFill>
-                  <a:srgbClr val="2C3E50"/>
+                <a:spcPts val="300"/>
+              </a:spcAft>
+              <a:defRPr sz="800" b="0">
+                <a:solidFill>
+                  <a:srgbClr val="CBD5E1"/>
                 </a:solidFill>
                 <a:latin typeface="Georgia"/>
               </a:defRPr>
             </a:pPr>
             <a:r>
-              <a:t>1. Bureau of Police Research &amp; Development (BPR&amp;D) — Smart Policing Directives &amp; AI Crime Analysis Guidelines (2024–2026).</a:t>
+              <a:t>1. National Technical Research Organisation (NTRO) — SIH26150 Multi-Vendor DVR/NVR Forensic Standards (Hikvision, Dahua, CP Plus, Honeywell, Uniview).</a:t>
             </a:r>
             <a:endParaRPr lang="en-IN" sz="900" b="0" i="0" u="none" strike="noStrike" cap="none" dirty="0">
               <a:solidFill>
@@ -17710,37 +17458,43 @@
           </a:p>
           <a:p>
             <a:pPr>
-              <a:defRPr sz="750" b="0">
-                <a:solidFill>
-                  <a:srgbClr val="2C3E50"/>
-                </a:solidFill>
-                <a:latin typeface="Georgia"/>
+              <a:spcAft>
+                <a:spcPts val="300"/>
+              </a:spcAft>
+              <a:defRPr sz="800">
+                <a:solidFill>
+                  <a:srgbClr val="CBD5E1"/>
+                </a:solidFill>
               </a:defRPr>
             </a:pPr>
             <a:r>
-              <a:t>2. Ministry of Home Affairs, Govt. of India — Bharatiya Nagarik Suraksha Sanhita (BNSS 2023 Sec 94, 107, 176) &amp; BSA Sec 65B Electronic Evidence.</a:t>
+              <a:t>2. Bureau of Police Research &amp; Development (BPR&amp;D) — Smart Policing Directives &amp; AI Crime Analysis Guidelines (2024–2026).</a:t>
             </a:r>
           </a:p>
           <a:p>
             <a:pPr>
-              <a:defRPr sz="750" b="0">
-                <a:solidFill>
-                  <a:srgbClr val="2C3E50"/>
-                </a:solidFill>
-                <a:latin typeface="Georgia"/>
+              <a:spcAft>
+                <a:spcPts val="300"/>
+              </a:spcAft>
+              <a:defRPr sz="800">
+                <a:solidFill>
+                  <a:srgbClr val="CBD5E1"/>
+                </a:solidFill>
               </a:defRPr>
             </a:pPr>
             <a:r>
-              <a:t>3. National Technical Research Organisation (NTRO) — SIH26150 Multi-Vendor DVR/NVR Forensic Standards (Hikvision, Dahua, CP Plus, Honeywell, Uniview).</a:t>
+              <a:t>3. Ministry of Home Affairs, Govt. of India — Bharatiya Nagarik Suraksha Sanhita (BNSS 2023 Sec 94, 107, 176) &amp; BSA Sec 65B Electronic Evidence.</a:t>
             </a:r>
           </a:p>
           <a:p>
             <a:pPr>
-              <a:defRPr sz="750" b="0">
-                <a:solidFill>
-                  <a:srgbClr val="2C3E50"/>
-                </a:solidFill>
-                <a:latin typeface="Georgia"/>
+              <a:spcAft>
+                <a:spcPts val="300"/>
+              </a:spcAft>
+              <a:defRPr sz="800">
+                <a:solidFill>
+                  <a:srgbClr val="CBD5E1"/>
+                </a:solidFill>
               </a:defRPr>
             </a:pPr>
             <a:r>
@@ -17749,11 +17503,13 @@
           </a:p>
           <a:p>
             <a:pPr>
-              <a:defRPr sz="750" b="0">
-                <a:solidFill>
-                  <a:srgbClr val="2C3E50"/>
-                </a:solidFill>
-                <a:latin typeface="Georgia"/>
+              <a:spcAft>
+                <a:spcPts val="300"/>
+              </a:spcAft>
+              <a:defRPr sz="800">
+                <a:solidFill>
+                  <a:srgbClr val="CBD5E1"/>
+                </a:solidFill>
               </a:defRPr>
             </a:pPr>
             <a:r>
@@ -18073,7 +17829,7 @@
               </a:defRPr>
             </a:pPr>
             <a:r>
-              <a:t>[ 6 ] SIH Problem Statements — sih.gov.in (PS 189 - BPR&amp;D / MHA &amp; SIH26150 - NTRO)</a:t>
+              <a:t>[ 6 ] SIH Problem Statement — sih.gov.in (SIH26150 - NTRO / MHA)</a:t>
             </a:r>
           </a:p>
         </p:txBody>

</xml_diff>

<commit_message>
fix: Increase text contrast to deep high-contrast colors, prevent box overflow, and verify portable kit photo on Slide 1
</commit_message>
<xml_diff>
--- a/frontend/public/SIH_Ideate_Template_AAROHAN-X.pptx
+++ b/frontend/public/SIH_Ideate_Template_AAROHAN-X.pptx
@@ -7549,7 +7549,7 @@
             <a:pPr>
               <a:defRPr sz="1300" b="1">
                 <a:solidFill>
-                  <a:srgbClr val="38BDF8"/>
+                  <a:srgbClr val="1D4ED8"/>
                 </a:solidFill>
                 <a:latin typeface="Segoe UI"/>
               </a:defRPr>
@@ -7594,7 +7594,7 @@
               </a:spcAft>
               <a:defRPr sz="1100" b="1">
                 <a:solidFill>
-                  <a:srgbClr val="FBBF24"/>
+                  <a:srgbClr val="B45309"/>
                 </a:solidFill>
                 <a:latin typeface="Segoe UI"/>
               </a:defRPr>
@@ -7640,9 +7640,9 @@
           <a:lstStyle/>
           <a:p>
             <a:pPr>
-              <a:defRPr sz="950" b="0">
-                <a:solidFill>
-                  <a:srgbClr val="FFFFFF"/>
+              <a:defRPr sz="950" b="1">
+                <a:solidFill>
+                  <a:srgbClr val="0B1F3A"/>
                 </a:solidFill>
                 <a:latin typeface="Segoe UI"/>
               </a:defRPr>
@@ -7681,7 +7681,7 @@
             <a:pPr>
               <a:defRPr sz="900" b="1">
                 <a:solidFill>
-                  <a:srgbClr val="CBD5E1"/>
+                  <a:srgbClr val="0F172A"/>
                 </a:solidFill>
                 <a:latin typeface="Segoe UI"/>
               </a:defRPr>
@@ -7724,15 +7724,15 @@
               <a:spcAft>
                 <a:spcPts val="0"/>
               </a:spcAft>
-              <a:defRPr sz="950" b="0">
-                <a:solidFill>
-                  <a:srgbClr val="FFFFFF"/>
+              <a:defRPr sz="900" b="1">
+                <a:solidFill>
+                  <a:srgbClr val="0F172A"/>
                 </a:solidFill>
                 <a:latin typeface="Segoe UI"/>
               </a:defRPr>
             </a:pPr>
             <a:r>
-              <a:t>Theme  –  Cyber Security &amp; Digital Forensics / Surveillance Evidence Extraction (Featuring Agentic Voice AI)</a:t>
+              <a:t>Theme  –  Cyber Security &amp; Digital Forensics / Surveillance Evidence Extraction</a:t>
             </a:r>
             <a:endParaRPr sz="1000" b="0" i="0" u="none" strike="noStrike" cap="none">
               <a:solidFill>
@@ -7772,9 +7772,9 @@
           <a:lstStyle/>
           <a:p>
             <a:pPr>
-              <a:defRPr sz="950" b="0">
-                <a:solidFill>
-                  <a:srgbClr val="FFFFFF"/>
+              <a:defRPr sz="900" b="1">
+                <a:solidFill>
+                  <a:srgbClr val="0F172A"/>
                 </a:solidFill>
                 <a:latin typeface="Segoe UI"/>
               </a:defRPr>
@@ -7817,9 +7817,9 @@
               <a:spcAft>
                 <a:spcPts val="0"/>
               </a:spcAft>
-              <a:defRPr sz="950" b="0">
-                <a:solidFill>
-                  <a:srgbClr val="FFFFFF"/>
+              <a:defRPr sz="900" b="1">
+                <a:solidFill>
+                  <a:srgbClr val="0F172A"/>
                 </a:solidFill>
                 <a:latin typeface="Segoe UI"/>
               </a:defRPr>
@@ -7871,9 +7871,9 @@
               <a:spcAft>
                 <a:spcPts val="0"/>
               </a:spcAft>
-              <a:defRPr sz="950" b="0">
-                <a:solidFill>
-                  <a:srgbClr val="FFFFFF"/>
+              <a:defRPr sz="900" b="1">
+                <a:solidFill>
+                  <a:srgbClr val="0F172A"/>
                 </a:solidFill>
                 <a:latin typeface="Segoe UI"/>
               </a:defRPr>
@@ -8027,12 +8027,15 @@
           </a:bodyPr>
           <a:lstStyle/>
           <a:p>
+            <a:pPr>
+              <a:defRPr sz="1300" b="1">
+                <a:solidFill>
+                  <a:srgbClr val="0B1F3A"/>
+                </a:solidFill>
+                <a:latin typeface="Segoe UI"/>
+              </a:defRPr>
+            </a:pPr>
             <a:r>
-              <a:rPr sz="1300" b="1">
-                <a:solidFill>
-                  <a:srgbClr val="38BDF8"/>
-                </a:solidFill>
-              </a:rPr>
               <a:t>PROPOSED SOLUTION — NCIS-TACTICAL (SIH26150 MULTI-VENDOR DVR/NVR &amp; AGENTIC AI)</a:t>
             </a:r>
           </a:p>
@@ -8231,9 +8234,9 @@
               <a:buSzPts val="1200"/>
               <a:buFont typeface="Cambria"/>
               <a:buNone/>
-              <a:defRPr sz="800" b="0">
-                <a:solidFill>
-                  <a:srgbClr val="CBD5E1"/>
+              <a:defRPr sz="1050" b="1">
+                <a:solidFill>
+                  <a:srgbClr val="0B1F3A"/>
                 </a:solidFill>
                 <a:latin typeface="Segoe UI"/>
               </a:defRPr>
@@ -8319,7 +8322,7 @@
           </a:ln>
         </p:spPr>
         <p:txBody>
-          <a:bodyPr spcFirstLastPara="1" wrap="square" lIns="0" tIns="0" rIns="0" bIns="0" anchor="t" anchorCtr="0">
+          <a:bodyPr spcFirstLastPara="1" wrap="square" lIns="73152" rIns="73152" anchor="t" anchorCtr="0">
             <a:noAutofit/>
           </a:bodyPr>
           <a:lstStyle/>
@@ -8329,30 +8332,33 @@
                 <a:spcPts val="0"/>
               </a:spcBef>
               <a:spcAft>
-                <a:spcPts val="0"/>
-              </a:spcAft>
-              <a:defRPr sz="800" b="0">
-                <a:solidFill>
-                  <a:srgbClr val="CBD5E1"/>
+                <a:spcPts val="100"/>
+              </a:spcAft>
+              <a:defRPr sz="780" b="1">
+                <a:solidFill>
+                  <a:srgbClr val="B45309"/>
                 </a:solidFill>
                 <a:latin typeface="Segoe UI"/>
               </a:defRPr>
             </a:pPr>
             <a:r>
-              <a:t>Core Problem — Proprietary Surveillance Chaos (SIH26150):</a:t>
+              <a:t>Core Problem (SIH26150):</a:t>
             </a:r>
           </a:p>
           <a:p>
             <a:pPr>
-              <a:defRPr sz="800" b="0">
-                <a:solidFill>
-                  <a:srgbClr val="CBD5E1"/>
+              <a:spcBef>
+                <a:spcPts val="0"/>
+              </a:spcBef>
+              <a:defRPr sz="700" b="0">
+                <a:solidFill>
+                  <a:srgbClr val="0F172A"/>
                 </a:solidFill>
                 <a:latin typeface="Segoe UI"/>
               </a:defRPr>
             </a:pPr>
             <a:r>
-              <a:t>Law enforcement struggles with heterogeneous CCTV/DVR/NVR systems (Hikvision, Dahua, CP Plus, Honeywell, Uniview) using proprietary filesystems (DHFS, HIK, WFS). Unstructured video, missing codecs, and corrupt sectors delay forensics by 7–30 days.</a:t>
+              <a:t>Heterogeneous CCTV systems (Hikvision, Dahua, CP Plus, Honeywell) use proprietary filesystems (DHFS, HIK, WFS). Missing codecs and corrupt sectors delay forensics by 7–30 days.</a:t>
             </a:r>
           </a:p>
         </p:txBody>
@@ -8423,7 +8429,7 @@
           </a:ln>
         </p:spPr>
         <p:txBody>
-          <a:bodyPr spcFirstLastPara="1" wrap="square" lIns="0" tIns="0" rIns="0" bIns="0" anchor="t" anchorCtr="0">
+          <a:bodyPr spcFirstLastPara="1" wrap="square" lIns="73152" rIns="73152" anchor="t" anchorCtr="0">
             <a:noAutofit/>
           </a:bodyPr>
           <a:lstStyle/>
@@ -8433,11 +8439,11 @@
                 <a:spcPts val="0"/>
               </a:spcBef>
               <a:spcAft>
-                <a:spcPts val="0"/>
-              </a:spcAft>
-              <a:defRPr sz="800" b="0">
-                <a:solidFill>
-                  <a:srgbClr val="CBD5E1"/>
+                <a:spcPts val="100"/>
+              </a:spcAft>
+              <a:defRPr sz="780" b="1">
+                <a:solidFill>
+                  <a:srgbClr val="B91C1C"/>
                 </a:solidFill>
                 <a:latin typeface="Segoe UI"/>
               </a:defRPr>
@@ -8448,15 +8454,18 @@
           </a:p>
           <a:p>
             <a:pPr>
-              <a:defRPr sz="800" b="0">
-                <a:solidFill>
-                  <a:srgbClr val="CBD5E1"/>
+              <a:spcBef>
+                <a:spcPts val="0"/>
+              </a:spcBef>
+              <a:defRPr sz="700" b="0">
+                <a:solidFill>
+                  <a:srgbClr val="0F172A"/>
                 </a:solidFill>
                 <a:latin typeface="Segoe UI"/>
               </a:defRPr>
             </a:pPr>
             <a:r>
-              <a:t>Legacy forensic tools lack standardized multi-vendor extraction, corrupt video frames, cost ₹25–40L/year, and offer zero autonomous AI voice assistance for on-scene officers during active raids.</a:t>
+              <a:t>Legacy tools lack multi-vendor extraction, corrupt video frames, cost ₹25–40L/yr, and offer zero autonomous AI voice assistance during active on-scene raids.</a:t>
             </a:r>
           </a:p>
         </p:txBody>
@@ -8527,7 +8536,7 @@
           </a:ln>
         </p:spPr>
         <p:txBody>
-          <a:bodyPr spcFirstLastPara="1" wrap="square" lIns="0" tIns="0" rIns="0" bIns="0" anchor="t" anchorCtr="0">
+          <a:bodyPr spcFirstLastPara="1" wrap="square" lIns="73152" rIns="73152" anchor="t" anchorCtr="0">
             <a:noAutofit/>
           </a:bodyPr>
           <a:lstStyle/>
@@ -8537,11 +8546,11 @@
                 <a:spcPts val="0"/>
               </a:spcBef>
               <a:spcAft>
-                <a:spcPts val="0"/>
-              </a:spcAft>
-              <a:defRPr sz="800" b="0">
-                <a:solidFill>
-                  <a:srgbClr val="CBD5E1"/>
+                <a:spcPts val="100"/>
+              </a:spcAft>
+              <a:defRPr sz="780" b="1">
+                <a:solidFill>
+                  <a:srgbClr val="0B1F3A"/>
                 </a:solidFill>
                 <a:latin typeface="Segoe UI"/>
               </a:defRPr>
@@ -8552,15 +8561,18 @@
           </a:p>
           <a:p>
             <a:pPr>
-              <a:defRPr sz="800" b="0">
-                <a:solidFill>
-                  <a:srgbClr val="CBD5E1"/>
+              <a:spcBef>
+                <a:spcPts val="0"/>
+              </a:spcBef>
+              <a:defRPr sz="700" b="0">
+                <a:solidFill>
+                  <a:srgbClr val="0F172A"/>
                 </a:solidFill>
                 <a:latin typeface="Segoe UI"/>
               </a:defRPr>
             </a:pPr>
             <a:r>
-              <a:t>Affects 16,000+ police stations, state cyber crime cells, NIA, NCB, and central intelligence agencies analyzing thousands of crime-scene CCTV hard drives nationwide.</a:t>
+              <a:t>Affects 16,000+ police stations, state cyber cells, NIA, NCB, and central agencies analyzing thousands of crime-scene CCTV hard drives nationwide.</a:t>
             </a:r>
           </a:p>
         </p:txBody>
@@ -8631,7 +8643,7 @@
           </a:ln>
         </p:spPr>
         <p:txBody>
-          <a:bodyPr spcFirstLastPara="1" wrap="square" lIns="0" tIns="0" rIns="0" bIns="0" anchor="t" anchorCtr="0">
+          <a:bodyPr spcFirstLastPara="1" wrap="square" lIns="73152" rIns="73152" anchor="t" anchorCtr="0">
             <a:noAutofit/>
           </a:bodyPr>
           <a:lstStyle/>
@@ -8641,11 +8653,11 @@
                 <a:spcPts val="0"/>
               </a:spcBef>
               <a:spcAft>
-                <a:spcPts val="0"/>
-              </a:spcAft>
-              <a:defRPr sz="800" b="0">
-                <a:solidFill>
-                  <a:srgbClr val="CBD5E1"/>
+                <a:spcPts val="100"/>
+              </a:spcAft>
+              <a:defRPr sz="780" b="1">
+                <a:solidFill>
+                  <a:srgbClr val="1D4ED8"/>
                 </a:solidFill>
                 <a:latin typeface="Segoe UI"/>
               </a:defRPr>
@@ -8656,15 +8668,18 @@
           </a:p>
           <a:p>
             <a:pPr>
-              <a:defRPr sz="800" b="0">
-                <a:solidFill>
-                  <a:srgbClr val="CBD5E1"/>
+              <a:spcBef>
+                <a:spcPts val="0"/>
+              </a:spcBef>
+              <a:defRPr sz="700" b="0">
+                <a:solidFill>
+                  <a:srgbClr val="0F172A"/>
                 </a:solidFill>
                 <a:latin typeface="Segoe UI"/>
               </a:defRPr>
             </a:pPr>
             <a:r>
-              <a:t>Inadmissible electronic video evidence, lost deleted footage from overwritten DVR sectors, delayed suspect identification, and fugitives escaping justice.</a:t>
+              <a:t>Inadmissible electronic video evidence, lost deleted footage from overwritten DVR sectors, delayed kingpin identification, and fugitives escaping justice.</a:t>
             </a:r>
           </a:p>
         </p:txBody>
@@ -8707,9 +8722,9 @@
               <a:buSzPts val="1200"/>
               <a:buFont typeface="Cambria"/>
               <a:buNone/>
-              <a:defRPr sz="800" b="0">
-                <a:solidFill>
-                  <a:srgbClr val="CBD5E1"/>
+              <a:defRPr sz="1050" b="1">
+                <a:solidFill>
+                  <a:srgbClr val="0B1F3A"/>
                 </a:solidFill>
                 <a:latin typeface="Segoe UI"/>
               </a:defRPr>
@@ -8794,12 +8809,14 @@
           </a:bodyPr>
           <a:lstStyle/>
           <a:p>
+            <a:pPr>
+              <a:defRPr sz="800" b="1">
+                <a:solidFill>
+                  <a:srgbClr val="0F766E"/>
+                </a:solidFill>
+              </a:defRPr>
+            </a:pPr>
             <a:r>
-              <a:rPr sz="850" b="1">
-                <a:solidFill>
-                  <a:srgbClr val="38BDF8"/>
-                </a:solidFill>
-              </a:rPr>
               <a:t>System Model: Multi-Vendor DVR + Agentic Voice AI</a:t>
             </a:r>
           </a:p>
@@ -8843,9 +8860,9 @@
               <a:buSzPts val="1100"/>
               <a:buFont typeface="Cambria"/>
               <a:buNone/>
-              <a:defRPr sz="800" b="0">
-                <a:solidFill>
-                  <a:srgbClr val="CBD5E1"/>
+              <a:defRPr sz="1050" b="1">
+                <a:solidFill>
+                  <a:srgbClr val="0B1F3A"/>
                 </a:solidFill>
                 <a:latin typeface="Segoe UI"/>
               </a:defRPr>
@@ -8931,7 +8948,7 @@
           </a:ln>
         </p:spPr>
         <p:txBody>
-          <a:bodyPr spcFirstLastPara="1" wrap="square" lIns="0" tIns="0" rIns="0" bIns="0" anchor="t" anchorCtr="0">
+          <a:bodyPr spcFirstLastPara="1" wrap="square" lIns="73152" tIns="54864" rIns="73152" bIns="54864" anchor="t" anchorCtr="0">
             <a:noAutofit/>
           </a:bodyPr>
           <a:lstStyle/>
@@ -8941,43 +8958,112 @@
                 <a:spcPts val="0"/>
               </a:spcBef>
               <a:spcAft>
-                <a:spcPts val="0"/>
-              </a:spcAft>
-              <a:defRPr sz="800" b="0">
-                <a:solidFill>
-                  <a:srgbClr val="CBD5E1"/>
+                <a:spcPts val="100"/>
+              </a:spcAft>
+              <a:defRPr sz="720" b="1">
+                <a:solidFill>
+                  <a:srgbClr val="1D4ED8"/>
                 </a:solidFill>
                 <a:latin typeface="Segoe UI"/>
               </a:defRPr>
             </a:pPr>
             <a:r>
-              <a:t>• Differentiator 1 — Standardized Multi-Vendor DVR Acquisition: Direct raw bitstream extraction supporting Hikvision, Dahua, CP Plus, Honeywell, and Uniview with write-blocker protection and zero timestamp contamination.</a:t>
+              <a:t>• Differentiator 1 — Standardized Multi-Vendor DVR Ingestion:</a:t>
             </a:r>
           </a:p>
           <a:p>
             <a:pPr>
-              <a:defRPr sz="800" b="0">
-                <a:solidFill>
-                  <a:srgbClr val="CBD5E1"/>
+              <a:spcBef>
+                <a:spcPts val="0"/>
+              </a:spcBef>
+              <a:spcAft>
+                <a:spcPts val="100"/>
+              </a:spcAft>
+              <a:defRPr sz="680" b="0">
+                <a:solidFill>
+                  <a:srgbClr val="0F172A"/>
                 </a:solidFill>
                 <a:latin typeface="Segoe UI"/>
               </a:defRPr>
             </a:pPr>
             <a:r>
-              <a:t>• Differentiator 2 — Autonomous Agentic AI Voice Module: Siri-style independent voice agent (EN/HI/TA) with acoustic wave visualizer, spoken brevity (≤3 sentences), and autonomous tool-calling loop (get_fir, extract_entities, rank_suspects).</a:t>
+              <a:t>Direct raw bitstream extraction supporting Hikvision, Dahua, CP Plus, Honeywell &amp; Uniview with write-blocker protection and zero timestamp contamination.</a:t>
             </a:r>
           </a:p>
           <a:p>
             <a:pPr>
-              <a:defRPr sz="800" b="0">
-                <a:solidFill>
-                  <a:srgbClr val="CBD5E1"/>
+              <a:spcBef>
+                <a:spcPts val="200"/>
+              </a:spcBef>
+              <a:spcAft>
+                <a:spcPts val="100"/>
+              </a:spcAft>
+              <a:defRPr sz="720" b="1">
+                <a:solidFill>
+                  <a:srgbClr val="0F766E"/>
                 </a:solidFill>
                 <a:latin typeface="Segoe UI"/>
               </a:defRPr>
             </a:pPr>
             <a:r>
-              <a:t>• Differentiator 3 — Unstructured Data to Court-Admissible Proof: Bypasses proprietary wrappers to recover deleted H.264/H.265 frames, auto-generating SHA-256 custody certificates under BNS 2023 Sec 63 &amp; BSA Sec 65B.</a:t>
+              <a:t>• Differentiator 2 — Autonomous Agentic AI Voice Module:</a:t>
+            </a:r>
+          </a:p>
+          <a:p>
+            <a:pPr>
+              <a:spcBef>
+                <a:spcPts val="0"/>
+              </a:spcBef>
+              <a:spcAft>
+                <a:spcPts val="100"/>
+              </a:spcAft>
+              <a:defRPr sz="680" b="0">
+                <a:solidFill>
+                  <a:srgbClr val="0F172A"/>
+                </a:solidFill>
+                <a:latin typeface="Segoe UI"/>
+              </a:defRPr>
+            </a:pPr>
+            <a:r>
+              <a:t>Siri-style independent voice agent (EN/HI/TA) with acoustic wave visualizer, spoken brevity (≤3 sentences), and autonomous tool-calling loop (get_fir, rank_suspects).</a:t>
+            </a:r>
+          </a:p>
+          <a:p>
+            <a:pPr>
+              <a:spcBef>
+                <a:spcPts val="200"/>
+              </a:spcBef>
+              <a:spcAft>
+                <a:spcPts val="100"/>
+              </a:spcAft>
+              <a:defRPr sz="720" b="1">
+                <a:solidFill>
+                  <a:srgbClr val="0B1F3A"/>
+                </a:solidFill>
+                <a:latin typeface="Segoe UI"/>
+              </a:defRPr>
+            </a:pPr>
+            <a:r>
+              <a:t>• Differentiator 3 — Unstructured Data to Court-Admissible Proof:</a:t>
+            </a:r>
+          </a:p>
+          <a:p>
+            <a:pPr>
+              <a:spcBef>
+                <a:spcPts val="0"/>
+              </a:spcBef>
+              <a:spcAft>
+                <a:spcPts val="100"/>
+              </a:spcAft>
+              <a:defRPr sz="680" b="0">
+                <a:solidFill>
+                  <a:srgbClr val="0F172A"/>
+                </a:solidFill>
+                <a:latin typeface="Segoe UI"/>
+              </a:defRPr>
+            </a:pPr>
+            <a:r>
+              <a:t>Bypasses proprietary wrappers to recover deleted H.264/H.265 frames, auto-generating SHA-256 custody certificates under BNS 2023 Sec 63 &amp; BSA Sec 65B.</a:t>
             </a:r>
           </a:p>
         </p:txBody>
@@ -9020,17 +9106,13 @@
               <a:buSzPts val="1200"/>
               <a:buFont typeface="Cambria"/>
               <a:buNone/>
+              <a:defRPr sz="1050" b="1">
+                <a:solidFill>
+                  <a:srgbClr val="0B1F3A"/>
+                </a:solidFill>
+              </a:defRPr>
             </a:pPr>
             <a:r>
-              <a:rPr lang="en" sz="1200" b="1" i="0" u="none" strike="noStrike" cap="none" dirty="0">
-                <a:solidFill>
-                  <a:srgbClr val="1F618D"/>
-                </a:solidFill>
-                <a:latin typeface="Times New Roman" panose="02020603050405020304" pitchFamily="18" charset="0"/>
-                <a:ea typeface="Cambria"/>
-                <a:cs typeface="Times New Roman" panose="02020603050405020304" pitchFamily="18" charset="0"/>
-                <a:sym typeface="Cambria"/>
-              </a:rPr>
               <a:t>Key Features</a:t>
             </a:r>
             <a:endParaRPr sz="1200" b="0" i="0" u="none" strike="noStrike" cap="none" dirty="0">
@@ -9168,7 +9250,7 @@
           </a:ln>
         </p:spPr>
         <p:txBody>
-          <a:bodyPr spcFirstLastPara="1" wrap="square" lIns="0" tIns="0" rIns="0" bIns="0" anchor="t" anchorCtr="0">
+          <a:bodyPr spcFirstLastPara="1" wrap="square" lIns="36576" tIns="18288" rIns="36576" bIns="18288" anchor="t" anchorCtr="0">
             <a:noAutofit/>
           </a:bodyPr>
           <a:lstStyle/>
@@ -9178,11 +9260,11 @@
                 <a:spcPts val="0"/>
               </a:spcBef>
               <a:spcAft>
-                <a:spcPts val="0"/>
-              </a:spcAft>
-              <a:defRPr sz="800" b="0">
-                <a:solidFill>
-                  <a:srgbClr val="CBD5E1"/>
+                <a:spcPts val="100"/>
+              </a:spcAft>
+              <a:defRPr sz="750" b="1">
+                <a:solidFill>
+                  <a:srgbClr val="0B1F3A"/>
                 </a:solidFill>
                 <a:latin typeface="Segoe UI"/>
               </a:defRPr>
@@ -9202,15 +9284,18 @@
           </a:p>
           <a:p>
             <a:pPr>
-              <a:defRPr sz="800" b="0">
-                <a:solidFill>
-                  <a:srgbClr val="CBD5E1"/>
+              <a:spcBef>
+                <a:spcPts val="0"/>
+              </a:spcBef>
+              <a:defRPr sz="680" b="0">
+                <a:solidFill>
+                  <a:srgbClr val="0F172A"/>
                 </a:solidFill>
                 <a:latin typeface="Segoe UI"/>
               </a:defRPr>
             </a:pPr>
             <a:r>
-              <a:t>Sub-50ms multi-camera ingestion, OpenCV facial embedding vectors, and real-time telemetry stream</a:t>
+              <a:t>Sub-50ms multi-camera ingestion, OpenCV facial embedding vectors, and real-time stream.</a:t>
             </a:r>
           </a:p>
         </p:txBody>
@@ -9338,7 +9423,7 @@
           </a:ln>
         </p:spPr>
         <p:txBody>
-          <a:bodyPr spcFirstLastPara="1" wrap="square" lIns="0" tIns="0" rIns="0" bIns="0" anchor="t" anchorCtr="0">
+          <a:bodyPr spcFirstLastPara="1" wrap="square" lIns="36576" tIns="18288" rIns="36576" bIns="18288" anchor="t" anchorCtr="0">
             <a:noAutofit/>
           </a:bodyPr>
           <a:lstStyle/>
@@ -9348,11 +9433,11 @@
                 <a:spcPts val="0"/>
               </a:spcBef>
               <a:spcAft>
-                <a:spcPts val="0"/>
-              </a:spcAft>
-              <a:defRPr sz="800" b="0">
-                <a:solidFill>
-                  <a:srgbClr val="CBD5E1"/>
+                <a:spcPts val="100"/>
+              </a:spcAft>
+              <a:defRPr sz="750" b="1">
+                <a:solidFill>
+                  <a:srgbClr val="1D4ED8"/>
                 </a:solidFill>
                 <a:latin typeface="Segoe UI"/>
               </a:defRPr>
@@ -9372,15 +9457,18 @@
           </a:p>
           <a:p>
             <a:pPr>
-              <a:defRPr sz="800" b="0">
-                <a:solidFill>
-                  <a:srgbClr val="CBD5E1"/>
+              <a:spcBef>
+                <a:spcPts val="0"/>
+              </a:spcBef>
+              <a:defRPr sz="680" b="0">
+                <a:solidFill>
+                  <a:srgbClr val="0F172A"/>
                 </a:solidFill>
                 <a:latin typeface="Segoe UI"/>
               </a:defRPr>
             </a:pPr>
             <a:r>
-              <a:t>Standardized acquisition across Hikvision, Dahua, CP Plus, Honeywell, Uniview &amp; 131k sector carving</a:t>
+              <a:t>Standardized acquisition across Hikvision, Dahua, CP Plus, Honeywell &amp; 131k sector carving.</a:t>
             </a:r>
           </a:p>
         </p:txBody>
@@ -9508,7 +9596,7 @@
           </a:ln>
         </p:spPr>
         <p:txBody>
-          <a:bodyPr spcFirstLastPara="1" wrap="square" lIns="0" tIns="0" rIns="0" bIns="0" anchor="t" anchorCtr="0">
+          <a:bodyPr spcFirstLastPara="1" wrap="square" lIns="36576" tIns="18288" rIns="36576" bIns="18288" anchor="t" anchorCtr="0">
             <a:noAutofit/>
           </a:bodyPr>
           <a:lstStyle/>
@@ -9518,11 +9606,11 @@
                 <a:spcPts val="0"/>
               </a:spcBef>
               <a:spcAft>
-                <a:spcPts val="0"/>
-              </a:spcAft>
-              <a:defRPr sz="800" b="0">
-                <a:solidFill>
-                  <a:srgbClr val="CBD5E1"/>
+                <a:spcPts val="100"/>
+              </a:spcAft>
+              <a:defRPr sz="750" b="1">
+                <a:solidFill>
+                  <a:srgbClr val="0B1F3A"/>
                 </a:solidFill>
                 <a:latin typeface="Segoe UI"/>
               </a:defRPr>
@@ -9542,15 +9630,18 @@
           </a:p>
           <a:p>
             <a:pPr>
-              <a:defRPr sz="800" b="0">
-                <a:solidFill>
-                  <a:srgbClr val="CBD5E1"/>
+              <a:spcBef>
+                <a:spcPts val="0"/>
+              </a:spcBef>
+              <a:defRPr sz="680" b="0">
+                <a:solidFill>
+                  <a:srgbClr val="0F172A"/>
                 </a:solidFill>
                 <a:latin typeface="Segoe UI"/>
               </a:defRPr>
             </a:pPr>
             <a:r>
-              <a:t>Spectral GCN maps multi-camera suspect movements with 98.6% link precision &amp; Betweenness Centrality</a:t>
+              <a:t>Spectral GCN maps suspect networks with 98.6% precision &amp; Betweenness Centrality.</a:t>
             </a:r>
           </a:p>
         </p:txBody>
@@ -9678,7 +9769,7 @@
           </a:ln>
         </p:spPr>
         <p:txBody>
-          <a:bodyPr spcFirstLastPara="1" wrap="square" lIns="0" tIns="0" rIns="0" bIns="0" anchor="t" anchorCtr="0">
+          <a:bodyPr spcFirstLastPara="1" wrap="square" lIns="36576" tIns="18288" rIns="36576" bIns="18288" anchor="t" anchorCtr="0">
             <a:noAutofit/>
           </a:bodyPr>
           <a:lstStyle/>
@@ -9688,11 +9779,11 @@
                 <a:spcPts val="0"/>
               </a:spcBef>
               <a:spcAft>
-                <a:spcPts val="0"/>
-              </a:spcAft>
-              <a:defRPr sz="800" b="0">
-                <a:solidFill>
-                  <a:srgbClr val="CBD5E1"/>
+                <a:spcPts val="100"/>
+              </a:spcAft>
+              <a:defRPr sz="750" b="1">
+                <a:solidFill>
+                  <a:srgbClr val="0B1F3A"/>
                 </a:solidFill>
                 <a:latin typeface="Segoe UI"/>
               </a:defRPr>
@@ -9712,15 +9803,18 @@
           </a:p>
           <a:p>
             <a:pPr>
-              <a:defRPr sz="800" b="0">
-                <a:solidFill>
-                  <a:srgbClr val="CBD5E1"/>
+              <a:spcBef>
+                <a:spcPts val="0"/>
+              </a:spcBef>
+              <a:defRPr sz="680" b="0">
+                <a:solidFill>
+                  <a:srgbClr val="0F172A"/>
                 </a:solidFill>
                 <a:latin typeface="Segoe UI"/>
               </a:defRPr>
             </a:pPr>
             <a:r>
-              <a:t>Interactive GIS map with touch tracking, Haversine distance, dynamic ETA &amp; rapid dispatch</a:t>
+              <a:t>Interactive GIS map with touch tracking, Haversine distance, dynamic ETA &amp; rapid dispatch.</a:t>
             </a:r>
           </a:p>
         </p:txBody>
@@ -9848,7 +9942,7 @@
           </a:ln>
         </p:spPr>
         <p:txBody>
-          <a:bodyPr spcFirstLastPara="1" wrap="square" lIns="0" tIns="0" rIns="0" bIns="0" anchor="t" anchorCtr="0">
+          <a:bodyPr spcFirstLastPara="1" wrap="square" lIns="36576" tIns="18288" rIns="36576" bIns="18288" anchor="t" anchorCtr="0">
             <a:noAutofit/>
           </a:bodyPr>
           <a:lstStyle/>
@@ -9858,11 +9952,11 @@
                 <a:spcPts val="0"/>
               </a:spcBef>
               <a:spcAft>
-                <a:spcPts val="0"/>
-              </a:spcAft>
-              <a:defRPr sz="800" b="0">
-                <a:solidFill>
-                  <a:srgbClr val="CBD5E1"/>
+                <a:spcPts val="100"/>
+              </a:spcAft>
+              <a:defRPr sz="750" b="1">
+                <a:solidFill>
+                  <a:srgbClr val="0B1F3A"/>
                 </a:solidFill>
                 <a:latin typeface="Segoe UI"/>
               </a:defRPr>
@@ -9873,15 +9967,18 @@
           </a:p>
           <a:p>
             <a:pPr>
-              <a:defRPr sz="800" b="0">
-                <a:solidFill>
-                  <a:srgbClr val="CBD5E1"/>
+              <a:spcBef>
+                <a:spcPts val="0"/>
+              </a:spcBef>
+              <a:defRPr sz="680" b="0">
+                <a:solidFill>
+                  <a:srgbClr val="0F172A"/>
                 </a:solidFill>
                 <a:latin typeface="Segoe UI"/>
               </a:defRPr>
             </a:pPr>
             <a:r>
-              <a:t>Physical write-blocker locks, multi-bus selector (PCIe/SATA/USB), raw hexadecimal bitstream dump</a:t>
+              <a:t>Physical write-blocker locks, multi-bus selector (PCIe/SATA/USB), raw hex bitstream dump.</a:t>
             </a:r>
           </a:p>
         </p:txBody>
@@ -10009,7 +10106,7 @@
           </a:ln>
         </p:spPr>
         <p:txBody>
-          <a:bodyPr spcFirstLastPara="1" wrap="square" lIns="0" tIns="0" rIns="0" bIns="0" anchor="t" anchorCtr="0">
+          <a:bodyPr spcFirstLastPara="1" wrap="square" lIns="36576" tIns="18288" rIns="36576" bIns="18288" anchor="t" anchorCtr="0">
             <a:noAutofit/>
           </a:bodyPr>
           <a:lstStyle/>
@@ -10019,11 +10116,11 @@
                 <a:spcPts val="0"/>
               </a:spcBef>
               <a:spcAft>
-                <a:spcPts val="0"/>
-              </a:spcAft>
-              <a:defRPr sz="800" b="0">
-                <a:solidFill>
-                  <a:srgbClr val="CBD5E1"/>
+                <a:spcPts val="100"/>
+              </a:spcAft>
+              <a:defRPr sz="750" b="1">
+                <a:solidFill>
+                  <a:srgbClr val="0F766E"/>
                 </a:solidFill>
                 <a:latin typeface="Segoe UI"/>
               </a:defRPr>
@@ -10043,15 +10140,18 @@
           </a:p>
           <a:p>
             <a:pPr>
-              <a:defRPr sz="800" b="0">
-                <a:solidFill>
-                  <a:srgbClr val="CBD5E1"/>
+              <a:spcBef>
+                <a:spcPts val="0"/>
+              </a:spcBef>
+              <a:defRPr sz="680" b="0">
+                <a:solidFill>
+                  <a:srgbClr val="0F172A"/>
                 </a:solidFill>
                 <a:latin typeface="Segoe UI"/>
               </a:defRPr>
             </a:pPr>
             <a:r>
-              <a:t>Siri voice agent, multilingual NLP, auto BNSS 94/107 drafts &amp; 100% 50-case benchmark accuracy</a:t>
+              <a:t>Siri voice agent, multilingual NLP, auto BNSS 94/107 drafts &amp; 100% benchmark accuracy.</a:t>
             </a:r>
           </a:p>
         </p:txBody>
@@ -10190,12 +10290,15 @@
           </a:bodyPr>
           <a:lstStyle/>
           <a:p>
+            <a:pPr>
+              <a:defRPr sz="1300" b="1">
+                <a:solidFill>
+                  <a:srgbClr val="0B1F3A"/>
+                </a:solidFill>
+                <a:latin typeface="Segoe UI"/>
+              </a:defRPr>
+            </a:pPr>
             <a:r>
-              <a:rPr sz="1300" b="1">
-                <a:solidFill>
-                  <a:srgbClr val="38BDF8"/>
-                </a:solidFill>
-              </a:rPr>
               <a:t>TECHNICAL APPROACH &amp; PIPELINE (SIH26150 MULTI-VENDOR DVR TO AGENTIC ACTION)</a:t>
             </a:r>
           </a:p>
@@ -10525,34 +10628,34 @@
           </a:ln>
         </p:spPr>
         <p:txBody>
-          <a:bodyPr spcFirstLastPara="1" wrap="square" lIns="0" tIns="0" rIns="0" bIns="0" anchor="t" anchorCtr="0">
+          <a:bodyPr spcFirstLastPara="1" wrap="square" lIns="36576" tIns="0" rIns="36576" bIns="0" anchor="t" anchorCtr="0">
             <a:noAutofit/>
           </a:bodyPr>
           <a:lstStyle/>
           <a:p>
-            <a:pPr>
-              <a:defRPr sz="800" b="0">
-                <a:solidFill>
-                  <a:srgbClr val="CBD5E1"/>
+            <a:pPr algn="ctr">
+              <a:defRPr sz="720" b="1">
+                <a:solidFill>
+                  <a:srgbClr val="0B1F3A"/>
                 </a:solidFill>
                 <a:latin typeface="Segoe UI"/>
               </a:defRPr>
             </a:pPr>
             <a:r>
-              <a:t>1. Multi-Vendor DVR Acquisition</a:t>
+              <a:t>1. Multi-Vendor DVR</a:t>
             </a:r>
           </a:p>
           <a:p>
-            <a:pPr>
-              <a:defRPr sz="800" b="0">
-                <a:solidFill>
-                  <a:srgbClr val="CBD5E1"/>
+            <a:pPr algn="ctr">
+              <a:defRPr sz="720" b="1">
+                <a:solidFill>
+                  <a:srgbClr val="0B1F3A"/>
                 </a:solidFill>
                 <a:latin typeface="Segoe UI"/>
               </a:defRPr>
             </a:pPr>
             <a:r>
-              <a:t>(Hikvision, Dahua, CP Plus)</a:t>
+              <a:t>Acquisition (SIH26150)</a:t>
             </a:r>
           </a:p>
         </p:txBody>
@@ -10992,34 +11095,34 @@
           </a:ln>
         </p:spPr>
         <p:txBody>
-          <a:bodyPr spcFirstLastPara="1" wrap="square" lIns="0" tIns="0" rIns="0" bIns="0" anchor="t" anchorCtr="0">
+          <a:bodyPr spcFirstLastPara="1" wrap="square" lIns="36576" tIns="0" rIns="36576" bIns="0" anchor="t" anchorCtr="0">
             <a:noAutofit/>
           </a:bodyPr>
           <a:lstStyle/>
           <a:p>
-            <a:pPr>
-              <a:defRPr sz="800" b="0">
-                <a:solidFill>
-                  <a:srgbClr val="CBD5E1"/>
+            <a:pPr algn="ctr">
+              <a:defRPr sz="720" b="1">
+                <a:solidFill>
+                  <a:srgbClr val="0B1F3A"/>
                 </a:solidFill>
                 <a:latin typeface="Segoe UI"/>
               </a:defRPr>
             </a:pPr>
             <a:r>
-              <a:t>3. Agentic AI Voice Module</a:t>
+              <a:t>3. Agentic AI Voice &amp;</a:t>
             </a:r>
           </a:p>
           <a:p>
-            <a:pPr>
-              <a:defRPr sz="800" b="0">
-                <a:solidFill>
-                  <a:srgbClr val="CBD5E1"/>
+            <a:pPr algn="ctr">
+              <a:defRPr sz="720" b="1">
+                <a:solidFill>
+                  <a:srgbClr val="0B1F3A"/>
                 </a:solidFill>
                 <a:latin typeface="Segoe UI"/>
               </a:defRPr>
             </a:pPr>
             <a:r>
-              <a:t>&amp; Copilot Reasoning Loop</a:t>
+              <a:t>Copilot Reasoning Loop</a:t>
             </a:r>
           </a:p>
         </p:txBody>
@@ -11256,28 +11359,28 @@
           </a:ln>
         </p:spPr>
         <p:txBody>
-          <a:bodyPr spcFirstLastPara="1" wrap="square" lIns="0" tIns="0" rIns="0" bIns="0" anchor="t" anchorCtr="0">
+          <a:bodyPr spcFirstLastPara="1" wrap="square" lIns="36576" tIns="0" rIns="36576" bIns="0" anchor="t" anchorCtr="0">
             <a:noAutofit/>
           </a:bodyPr>
           <a:lstStyle/>
           <a:p>
-            <a:pPr>
-              <a:defRPr sz="800" b="0">
-                <a:solidFill>
-                  <a:srgbClr val="CBD5E1"/>
+            <a:pPr algn="ctr">
+              <a:defRPr sz="720" b="1">
+                <a:solidFill>
+                  <a:srgbClr val="0B1F3A"/>
                 </a:solidFill>
                 <a:latin typeface="Segoe UI"/>
               </a:defRPr>
             </a:pPr>
             <a:r>
-              <a:t>4. Spectral GCN Syndicate</a:t>
+              <a:t>4. Spectral GCN</a:t>
             </a:r>
           </a:p>
           <a:p>
-            <a:pPr>
-              <a:defRPr sz="800" b="0">
-                <a:solidFill>
-                  <a:srgbClr val="CBD5E1"/>
+            <a:pPr algn="ctr">
+              <a:defRPr sz="720" b="1">
+                <a:solidFill>
+                  <a:srgbClr val="0B1F3A"/>
                 </a:solidFill>
                 <a:latin typeface="Segoe UI"/>
               </a:defRPr>
@@ -11520,34 +11623,34 @@
           </a:ln>
         </p:spPr>
         <p:txBody>
-          <a:bodyPr spcFirstLastPara="1" wrap="square" lIns="0" tIns="0" rIns="0" bIns="0" anchor="t" anchorCtr="0">
+          <a:bodyPr spcFirstLastPara="1" wrap="square" lIns="36576" tIns="0" rIns="36576" bIns="0" anchor="t" anchorCtr="0">
             <a:noAutofit/>
           </a:bodyPr>
           <a:lstStyle/>
           <a:p>
-            <a:pPr>
-              <a:defRPr sz="800" b="0">
-                <a:solidFill>
-                  <a:srgbClr val="CBD5E1"/>
+            <a:pPr algn="ctr">
+              <a:defRPr sz="720" b="1">
+                <a:solidFill>
+                  <a:srgbClr val="0B1F3A"/>
                 </a:solidFill>
                 <a:latin typeface="Segoe UI"/>
               </a:defRPr>
             </a:pPr>
             <a:r>
-              <a:t>5. Dual ERSS Patrol Mesh</a:t>
+              <a:t>5. Dual ERSS Mesh &amp;</a:t>
             </a:r>
           </a:p>
           <a:p>
-            <a:pPr>
-              <a:defRPr sz="800" b="0">
-                <a:solidFill>
-                  <a:srgbClr val="CBD5E1"/>
+            <a:pPr algn="ctr">
+              <a:defRPr sz="720" b="1">
+                <a:solidFill>
+                  <a:srgbClr val="0B1F3A"/>
                 </a:solidFill>
                 <a:latin typeface="Segoe UI"/>
               </a:defRPr>
             </a:pPr>
             <a:r>
-              <a:t>&amp; BNSS 63 Evidence Seal</a:t>
+              <a:t>BNSS 63 Judicial Seal</a:t>
             </a:r>
           </a:p>
         </p:txBody>
@@ -11636,9 +11739,9 @@
               <a:buSzPts val="1000"/>
               <a:buFont typeface="Cambria"/>
               <a:buNone/>
-              <a:defRPr sz="800" b="0">
-                <a:solidFill>
-                  <a:srgbClr val="CBD5E1"/>
+              <a:defRPr sz="900" b="1">
+                <a:solidFill>
+                  <a:srgbClr val="0B1F3A"/>
                 </a:solidFill>
                 <a:latin typeface="Segoe UI"/>
               </a:defRPr>
@@ -11678,7 +11781,7 @@
           </a:ln>
         </p:spPr>
         <p:txBody>
-          <a:bodyPr spcFirstLastPara="1" wrap="square" lIns="0" tIns="0" rIns="0" bIns="0" anchor="t" anchorCtr="0">
+          <a:bodyPr spcFirstLastPara="1" wrap="square" lIns="73152" rIns="73152" anchor="t" anchorCtr="0">
             <a:noAutofit/>
           </a:bodyPr>
           <a:lstStyle/>
@@ -11688,17 +11791,17 @@
                 <a:spcPts val="0"/>
               </a:spcBef>
               <a:spcAft>
-                <a:spcPts val="0"/>
-              </a:spcAft>
-              <a:defRPr sz="800" b="0">
-                <a:solidFill>
-                  <a:srgbClr val="CBD5E1"/>
+                <a:spcPts val="100"/>
+              </a:spcAft>
+              <a:defRPr sz="680" b="0">
+                <a:solidFill>
+                  <a:srgbClr val="0F172A"/>
                 </a:solidFill>
                 <a:latin typeface="Segoe UI"/>
               </a:defRPr>
             </a:pPr>
             <a:r>
-              <a:t>• Forensics : SIH26150 Multi-Vendor DVR Tool, Hardware Write-Blocker Bus (PCIe NVMe, SATA III, USB 3.2, JTAG)</a:t>
+              <a:t>• Forensics : SIH26150 Multi-Vendor DVR Tool, Hardware Bus (PCIe, SATA, USB)</a:t>
             </a:r>
             <a:endParaRPr sz="800" b="0" i="0" u="none" strike="noStrike" cap="none" dirty="0">
               <a:solidFill>
@@ -11712,41 +11815,50 @@
           </a:p>
           <a:p>
             <a:pPr>
-              <a:defRPr sz="800" b="0">
-                <a:solidFill>
-                  <a:srgbClr val="CBD5E1"/>
+              <a:spcAft>
+                <a:spcPts val="100"/>
+              </a:spcAft>
+              <a:defRPr sz="680" b="0">
+                <a:solidFill>
+                  <a:srgbClr val="0F172A"/>
                 </a:solidFill>
                 <a:latin typeface="Segoe UI"/>
               </a:defRPr>
             </a:pPr>
             <a:r>
-              <a:t>• AI/ML &amp; NLP: Hailo-8L Edge AI (26 TOPS), PyTorch Geometric GCN (98.6%), SpaCy Indian Legal NER</a:t>
+              <a:t>• AI/ML/NLP : Hailo NPU (26 TOPS), PyG Spectral GCN (98.6%), Legal SpaCy NER</a:t>
             </a:r>
           </a:p>
           <a:p>
             <a:pPr>
-              <a:defRPr sz="800" b="0">
-                <a:solidFill>
-                  <a:srgbClr val="CBD5E1"/>
+              <a:spcAft>
+                <a:spcPts val="100"/>
+              </a:spcAft>
+              <a:defRPr sz="680" b="0">
+                <a:solidFill>
+                  <a:srgbClr val="0F172A"/>
                 </a:solidFill>
                 <a:latin typeface="Segoe UI"/>
               </a:defRPr>
             </a:pPr>
             <a:r>
-              <a:t>• Frontend  : React 18, Tailwind CSS, Apple iOS Glassmorphism UI, Web Speech API / TTS, Siri Orb Visualizer</a:t>
+              <a:t>• Frontend  : React 18, Tailwind CSS, Apple iOS Glassmorphism, Web Speech API</a:t>
             </a:r>
           </a:p>
           <a:p>
             <a:pPr>
-              <a:defRPr sz="800" b="0">
-                <a:solidFill>
-                  <a:srgbClr val="CBD5E1"/>
+              <a:spcAft>
+                <a:spcPts val="100"/>
+              </a:spcAft>
+              <a:defRPr sz="680" b="0">
+                <a:solidFill>
+                  <a:srgbClr val="0F172A"/>
                 </a:solidFill>
                 <a:latin typeface="Segoe UI"/>
               </a:defRPr>
             </a:pPr>
             <a:r>
-              <a:t>• Backend   : Python FastAPI async, OpenCV Headless, Redis Pub/Sub, PostgreSQL 15 (Air-gapped capability)</a:t>
+              <a:t>• Backend   : Python FastAPI async, OpenCV Headless, Redis Pub/Sub, PostgreSQL</a:t>
             </a:r>
           </a:p>
         </p:txBody>
@@ -11835,9 +11947,9 @@
               <a:buSzPts val="1000"/>
               <a:buFont typeface="Cambria"/>
               <a:buNone/>
-              <a:defRPr sz="800" b="0">
-                <a:solidFill>
-                  <a:srgbClr val="CBD5E1"/>
+              <a:defRPr sz="900" b="1">
+                <a:solidFill>
+                  <a:srgbClr val="0B1F3A"/>
                 </a:solidFill>
                 <a:latin typeface="Segoe UI"/>
               </a:defRPr>
@@ -11877,7 +11989,7 @@
           </a:ln>
         </p:spPr>
         <p:txBody>
-          <a:bodyPr spcFirstLastPara="1" wrap="square" lIns="0" tIns="0" rIns="0" bIns="0" anchor="t" anchorCtr="0">
+          <a:bodyPr spcFirstLastPara="1" wrap="square" lIns="73152" rIns="73152" anchor="t" anchorCtr="0">
             <a:noAutofit/>
           </a:bodyPr>
           <a:lstStyle/>
@@ -11887,17 +11999,17 @@
                 <a:spcPts val="500"/>
               </a:spcBef>
               <a:spcAft>
-                <a:spcPts val="0"/>
-              </a:spcAft>
-              <a:defRPr sz="800" b="0">
-                <a:solidFill>
-                  <a:srgbClr val="CBD5E1"/>
+                <a:spcPts val="100"/>
+              </a:spcAft>
+              <a:defRPr sz="680" b="0">
+                <a:solidFill>
+                  <a:srgbClr val="0F172A"/>
                 </a:solidFill>
                 <a:latin typeface="Segoe UI"/>
               </a:defRPr>
             </a:pPr>
             <a:r>
-              <a:t>• Video Parsing: Bypasses proprietary DVR containers (DHFS, HIK, WFS) extracting native H.264/H.265 frames in &lt;180s</a:t>
+              <a:t>• Video Parsing: Decodes DHFS, HIK, WFS extracting H.264/H.265 frames in &lt;180s</a:t>
             </a:r>
             <a:endParaRPr lang="en" sz="800" b="0" i="0" u="none" strike="noStrike" cap="none" dirty="0">
               <a:solidFill>
@@ -11911,41 +12023,50 @@
           </a:p>
           <a:p>
             <a:pPr>
-              <a:defRPr sz="800" b="0">
-                <a:solidFill>
-                  <a:srgbClr val="CBD5E1"/>
+              <a:spcAft>
+                <a:spcPts val="100"/>
+              </a:spcAft>
+              <a:defRPr sz="680" b="0">
+                <a:solidFill>
+                  <a:srgbClr val="0F172A"/>
                 </a:solidFill>
                 <a:latin typeface="Segoe UI"/>
               </a:defRPr>
             </a:pPr>
             <a:r>
-              <a:t>• Voice Agent  : Siri Voice Orb Visualizer with dynamic acoustic waves; multilingual recognition (EN, HI, TA)</a:t>
+              <a:t>• Voice Copilot: Siri Voice Orb Visualizer with multi-turn audio (EN, HI, TA)</a:t>
             </a:r>
           </a:p>
           <a:p>
             <a:pPr>
-              <a:defRPr sz="800" b="0">
-                <a:solidFill>
-                  <a:srgbClr val="CBD5E1"/>
+              <a:spcAft>
+                <a:spcPts val="100"/>
+              </a:spcAft>
+              <a:defRPr sz="680" b="0">
+                <a:solidFill>
+                  <a:srgbClr val="0F172A"/>
                 </a:solidFill>
                 <a:latin typeface="Segoe UI"/>
               </a:defRPr>
             </a:pPr>
             <a:r>
-              <a:t>• Brevity      : Spoken responses strictly capped at ≤3 sentences for tactical radio brevity</a:t>
+              <a:t>• Spoken Voice : Concise replies strictly ≤3 sentences for tactical radio brevity</a:t>
             </a:r>
           </a:p>
           <a:p>
             <a:pPr>
-              <a:defRPr sz="800" b="0">
-                <a:solidFill>
-                  <a:srgbClr val="CBD5E1"/>
+              <a:spcAft>
+                <a:spcPts val="100"/>
+              </a:spcAft>
+              <a:defRPr sz="680" b="0">
+                <a:solidFill>
+                  <a:srgbClr val="0F172A"/>
                 </a:solidFill>
                 <a:latin typeface="Segoe UI"/>
               </a:defRPr>
             </a:pPr>
             <a:r>
-              <a:t>• Legal Engine : Autonomous tool loop generating BNSS 2023 Sec 94 (CDR), Sec 107 (Freeze) requisitions in 5s</a:t>
+              <a:t>• Legal Engine : Auto-generates BNSS 2023 Sec 94/107 requisitions in under 5s</a:t>
             </a:r>
           </a:p>
         </p:txBody>
@@ -12034,9 +12155,9 @@
               <a:buSzPts val="1000"/>
               <a:buFont typeface="Cambria"/>
               <a:buNone/>
-              <a:defRPr sz="800" b="0">
-                <a:solidFill>
-                  <a:srgbClr val="CBD5E1"/>
+              <a:defRPr sz="900" b="1">
+                <a:solidFill>
+                  <a:srgbClr val="0B1F3A"/>
                 </a:solidFill>
                 <a:latin typeface="Segoe UI"/>
               </a:defRPr>
@@ -12076,7 +12197,7 @@
           </a:ln>
         </p:spPr>
         <p:txBody>
-          <a:bodyPr spcFirstLastPara="1" wrap="square" lIns="0" tIns="0" rIns="0" bIns="0" anchor="t" anchorCtr="0">
+          <a:bodyPr spcFirstLastPara="1" wrap="square" lIns="73152" rIns="73152" anchor="t" anchorCtr="0">
             <a:noAutofit/>
           </a:bodyPr>
           <a:lstStyle/>
@@ -12086,17 +12207,17 @@
                 <a:spcPts val="500"/>
               </a:spcBef>
               <a:spcAft>
-                <a:spcPts val="0"/>
-              </a:spcAft>
-              <a:defRPr sz="800" b="0">
-                <a:solidFill>
-                  <a:srgbClr val="CBD5E1"/>
+                <a:spcPts val="100"/>
+              </a:spcAft>
+              <a:defRPr sz="680" b="0">
+                <a:solidFill>
+                  <a:srgbClr val="0F172A"/>
                 </a:solidFill>
                 <a:latin typeface="Segoe UI"/>
               </a:defRPr>
             </a:pPr>
             <a:r>
-              <a:t>• Status : 100% Working Production Platform (Live Vercel &amp; GitHub Deployed)</a:t>
+              <a:t>• Deployment : 100% Live production portal at cyber-kit-police.vercel.app</a:t>
             </a:r>
             <a:endParaRPr lang="en" sz="800" b="0" i="0" u="none" strike="noStrike" cap="none" dirty="0">
               <a:solidFill>
@@ -12110,41 +12231,50 @@
           </a:p>
           <a:p>
             <a:pPr>
-              <a:defRPr sz="800" b="0">
-                <a:solidFill>
-                  <a:srgbClr val="CBD5E1"/>
+              <a:spcAft>
+                <a:spcPts val="100"/>
+              </a:spcAft>
+              <a:defRPr sz="680" b="0">
+                <a:solidFill>
+                  <a:srgbClr val="0F172A"/>
                 </a:solidFill>
                 <a:latin typeface="Segoe UI"/>
               </a:defRPr>
             </a:pPr>
             <a:r>
-              <a:t>• Built  : 6 Operational Modules, Siri Voice Agent, Hailo NPU triage, Interactive GIS, SIH26150 DVR Engine</a:t>
+              <a:t>• Architecture: 6 Operational Modules, Siri Voice Agent, Hailo NPU edge triage</a:t>
             </a:r>
           </a:p>
           <a:p>
             <a:pPr>
-              <a:defRPr sz="800" b="0">
-                <a:solidFill>
-                  <a:srgbClr val="CBD5E1"/>
+              <a:spcAft>
+                <a:spcPts val="100"/>
+              </a:spcAft>
+              <a:defRPr sz="680" b="0">
+                <a:solidFill>
+                  <a:srgbClr val="0F172A"/>
                 </a:solidFill>
                 <a:latin typeface="Segoe UI"/>
               </a:defRPr>
             </a:pPr>
             <a:r>
-              <a:t>• Live   : Deployed at cyber-kit-police.vercel.app (Publicly Accessible)</a:t>
+              <a:t>• Benchmarks  : 100% Entity F1, 100% Kingpin Top-3, 100% Evidence Gap Recall</a:t>
             </a:r>
           </a:p>
           <a:p>
             <a:pPr>
-              <a:defRPr sz="800" b="0">
-                <a:solidFill>
-                  <a:srgbClr val="CBD5E1"/>
+              <a:spcAft>
+                <a:spcPts val="100"/>
+              </a:spcAft>
+              <a:defRPr sz="680" b="0">
+                <a:solidFill>
+                  <a:srgbClr val="0F172A"/>
                 </a:solidFill>
                 <a:latin typeface="Segoe UI"/>
               </a:defRPr>
             </a:pPr>
             <a:r>
-              <a:t>• Eval   : 100% Entity F1, 100% Kingpin Top-3, 100% Evidence Gap Recall across 50 Synthetic FIR Cases</a:t>
+              <a:t>• Compliance  : Full adherence to BNSS 2023, BSA Sec 65B, BNS 63 &amp; DPDP 2023</a:t>
             </a:r>
           </a:p>
         </p:txBody>
@@ -12174,6 +12304,14 @@
           </a:bodyPr>
           <a:lstStyle/>
           <a:p>
+            <a:pPr>
+              <a:defRPr sz="1050" b="1">
+                <a:solidFill>
+                  <a:srgbClr val="0B1F3A"/>
+                </a:solidFill>
+                <a:latin typeface="Segoe UI"/>
+              </a:defRPr>
+            </a:pPr>
             <a:r>
               <a:t>Operational Platform: Live Interface + Agentic AI Voice Module &amp; Benchmark</a:t>
             </a:r>
@@ -12251,41 +12389,46 @@
           <a:lstStyle/>
           <a:p>
             <a:pPr>
+              <a:spcAft>
+                <a:spcPts val="200"/>
+              </a:spcAft>
               <a:defRPr sz="850" b="1">
                 <a:solidFill>
-                  <a:srgbClr val="38BDF8"/>
-                </a:solidFill>
-                <a:latin typeface="Georgia"/>
+                  <a:srgbClr val="1D4ED8"/>
+                </a:solidFill>
+                <a:latin typeface="Segoe UI"/>
               </a:defRPr>
             </a:pPr>
             <a:r>
-              <a:t>AGENTIC AI VOICE MODULE &amp; SIH26150 PRODUCTION HIGHLIGHTS:</a:t>
+              <a:t>AGENTIC AI VOICE MODULE &amp; SIH26150 HIGHLIGHTS:</a:t>
             </a:r>
           </a:p>
           <a:p>
             <a:pPr>
               <a:spcBef>
-                <a:spcPts val="150"/>
-              </a:spcBef>
-              <a:defRPr sz="750">
-                <a:solidFill>
-                  <a:srgbClr val="CBD5E1"/>
-                </a:solidFill>
+                <a:spcPts val="100"/>
+              </a:spcBef>
+              <a:defRPr sz="700" b="0">
+                <a:solidFill>
+                  <a:srgbClr val="0F172A"/>
+                </a:solidFill>
+                <a:latin typeface="Segoe UI"/>
               </a:defRPr>
             </a:pPr>
             <a:r>
-              <a:t>• SIH26150 DVR Core: Standardized CCTV evidence recovery across Hikvision, Dahua, CP Plus, Honeywell, Uniview.</a:t>
+              <a:t>• SIH26150 DVR Core: Standardized CCTV evidence recovery across Hikvision, Dahua, CP Plus &amp; Honeywell.</a:t>
             </a:r>
           </a:p>
           <a:p>
             <a:pPr>
               <a:spcBef>
-                <a:spcPts val="150"/>
-              </a:spcBef>
-              <a:defRPr sz="750">
-                <a:solidFill>
-                  <a:srgbClr val="CBD5E1"/>
-                </a:solidFill>
+                <a:spcPts val="100"/>
+              </a:spcBef>
+              <a:defRPr sz="700" b="0">
+                <a:solidFill>
+                  <a:srgbClr val="0F172A"/>
+                </a:solidFill>
+                <a:latin typeface="Segoe UI"/>
               </a:defRPr>
             </a:pPr>
             <a:r>
@@ -12295,12 +12438,13 @@
           <a:p>
             <a:pPr>
               <a:spcBef>
-                <a:spcPts val="150"/>
-              </a:spcBef>
-              <a:defRPr sz="750">
-                <a:solidFill>
-                  <a:srgbClr val="CBD5E1"/>
-                </a:solidFill>
+                <a:spcPts val="100"/>
+              </a:spcBef>
+              <a:defRPr sz="700" b="0">
+                <a:solidFill>
+                  <a:srgbClr val="0F172A"/>
+                </a:solidFill>
+                <a:latin typeface="Segoe UI"/>
               </a:defRPr>
             </a:pPr>
             <a:r>
@@ -12310,27 +12454,29 @@
           <a:p>
             <a:pPr>
               <a:spcBef>
-                <a:spcPts val="150"/>
-              </a:spcBef>
-              <a:defRPr sz="750">
-                <a:solidFill>
-                  <a:srgbClr val="CBD5E1"/>
-                </a:solidFill>
+                <a:spcPts val="100"/>
+              </a:spcBef>
+              <a:defRPr sz="700" b="0">
+                <a:solidFill>
+                  <a:srgbClr val="0F172A"/>
+                </a:solidFill>
+                <a:latin typeface="Segoe UI"/>
               </a:defRPr>
             </a:pPr>
             <a:r>
-              <a:t>• Missing Evidence Radar: Flags pending CCTV footage, CDRs, bank freezes; drafts BNSS 94/107/176 notices in 5s.</a:t>
+              <a:t>• Missing Evidence Radar: Flags pending CCTV footage, CDRs, bank freezes; drafts BNSS 94/107 notices in 5s.</a:t>
             </a:r>
           </a:p>
           <a:p>
             <a:pPr>
               <a:spcBef>
-                <a:spcPts val="150"/>
-              </a:spcBef>
-              <a:defRPr sz="750">
-                <a:solidFill>
-                  <a:srgbClr val="CBD5E1"/>
-                </a:solidFill>
+                <a:spcPts val="100"/>
+              </a:spcBef>
+              <a:defRPr sz="700" b="0">
+                <a:solidFill>
+                  <a:srgbClr val="0F172A"/>
+                </a:solidFill>
+                <a:latin typeface="Segoe UI"/>
               </a:defRPr>
             </a:pPr>
             <a:r>

</xml_diff>